<commit_message>
docs: migrate BehLand documentation to LitePaper V3 architecture
</commit_message>
<xml_diff>
--- a/PitchDeck/BehLand-PitchDeck-FA.pptx
+++ b/PitchDeck/BehLand-PitchDeck-FA.pptx
@@ -2,21 +2,26 @@
 <file path=ppt/presentation.xml><?xml version="1.0" encoding="utf-8"?>
 <p:presentation xmlns:a="http://schemas.openxmlformats.org/drawingml/2006/main" xmlns:r="http://schemas.openxmlformats.org/officeDocument/2006/relationships" xmlns:p="http://schemas.openxmlformats.org/presentationml/2006/main" saveSubsetFonts="1">
   <p:sldMasterIdLst>
-    <p:sldMasterId id="2147483660" r:id="rId1"/>
+    <p:sldMasterId id="2147483696" r:id="rId1"/>
   </p:sldMasterIdLst>
   <p:sldIdLst>
-    <p:sldId id="256" r:id="rId2"/>
-    <p:sldId id="257" r:id="rId3"/>
-    <p:sldId id="258" r:id="rId4"/>
-    <p:sldId id="259" r:id="rId5"/>
-    <p:sldId id="261" r:id="rId6"/>
-    <p:sldId id="262" r:id="rId7"/>
-    <p:sldId id="263" r:id="rId8"/>
-    <p:sldId id="264" r:id="rId9"/>
-    <p:sldId id="265" r:id="rId10"/>
-    <p:sldId id="266" r:id="rId11"/>
+    <p:sldId id="280" r:id="rId2"/>
+    <p:sldId id="281" r:id="rId3"/>
+    <p:sldId id="282" r:id="rId4"/>
+    <p:sldId id="283" r:id="rId5"/>
+    <p:sldId id="284" r:id="rId6"/>
+    <p:sldId id="285" r:id="rId7"/>
+    <p:sldId id="286" r:id="rId8"/>
+    <p:sldId id="287" r:id="rId9"/>
+    <p:sldId id="288" r:id="rId10"/>
+    <p:sldId id="289" r:id="rId11"/>
+    <p:sldId id="290" r:id="rId12"/>
+    <p:sldId id="291" r:id="rId13"/>
+    <p:sldId id="292" r:id="rId14"/>
+    <p:sldId id="296" r:id="rId15"/>
+    <p:sldId id="297" r:id="rId16"/>
   </p:sldIdLst>
-  <p:sldSz cx="9144000" cy="6858000" type="screen4x3"/>
+  <p:sldSz cx="8961438" cy="6308725"/>
   <p:notesSz cx="6858000" cy="9144000"/>
   <p:defaultTextStyle>
     <a:defPPr>
@@ -113,6 +118,11 @@
       </a:defRPr>
     </a:lvl9pPr>
   </p:defaultTextStyle>
+  <p:extLst>
+    <p:ext uri="{EFAFB233-063F-42B5-8137-9DF3F51BA10A}">
+      <p15:sldGuideLst xmlns:p15="http://schemas.microsoft.com/office/powerpoint/2012/main"/>
+    </p:ext>
+  </p:extLst>
 </p:presentation>
 </file>
 
@@ -145,15 +155,15 @@
         </p:nvSpPr>
         <p:spPr>
           <a:xfrm>
-            <a:off x="685800" y="1122363"/>
-            <a:ext cx="7772400" cy="2387600"/>
+            <a:off x="672108" y="1032470"/>
+            <a:ext cx="7617222" cy="2196371"/>
           </a:xfrm>
         </p:spPr>
         <p:txBody>
           <a:bodyPr anchor="b"/>
           <a:lstStyle>
             <a:lvl1pPr algn="ctr">
-              <a:defRPr sz="6000"/>
+              <a:defRPr sz="5519"/>
             </a:lvl1pPr>
           </a:lstStyle>
           <a:p>
@@ -177,8 +187,8 @@
         </p:nvSpPr>
         <p:spPr>
           <a:xfrm>
-            <a:off x="1143000" y="3602038"/>
-            <a:ext cx="6858000" cy="1655762"/>
+            <a:off x="1120180" y="3313541"/>
+            <a:ext cx="6721079" cy="1523148"/>
           </a:xfrm>
         </p:spPr>
         <p:txBody>
@@ -186,39 +196,39 @@
           <a:lstStyle>
             <a:lvl1pPr marL="0" indent="0" algn="ctr">
               <a:buNone/>
-              <a:defRPr sz="2400"/>
+              <a:defRPr sz="2208"/>
             </a:lvl1pPr>
-            <a:lvl2pPr marL="457200" indent="0" algn="ctr">
-              <a:buNone/>
-              <a:defRPr sz="2000"/>
+            <a:lvl2pPr marL="420578" indent="0" algn="ctr">
+              <a:buNone/>
+              <a:defRPr sz="1840"/>
             </a:lvl2pPr>
-            <a:lvl3pPr marL="914400" indent="0" algn="ctr">
-              <a:buNone/>
-              <a:defRPr sz="1800"/>
+            <a:lvl3pPr marL="841157" indent="0" algn="ctr">
+              <a:buNone/>
+              <a:defRPr sz="1656"/>
             </a:lvl3pPr>
-            <a:lvl4pPr marL="1371600" indent="0" algn="ctr">
-              <a:buNone/>
-              <a:defRPr sz="1600"/>
+            <a:lvl4pPr marL="1261735" indent="0" algn="ctr">
+              <a:buNone/>
+              <a:defRPr sz="1472"/>
             </a:lvl4pPr>
-            <a:lvl5pPr marL="1828800" indent="0" algn="ctr">
-              <a:buNone/>
-              <a:defRPr sz="1600"/>
+            <a:lvl5pPr marL="1682313" indent="0" algn="ctr">
+              <a:buNone/>
+              <a:defRPr sz="1472"/>
             </a:lvl5pPr>
-            <a:lvl6pPr marL="2286000" indent="0" algn="ctr">
-              <a:buNone/>
-              <a:defRPr sz="1600"/>
+            <a:lvl6pPr marL="2102891" indent="0" algn="ctr">
+              <a:buNone/>
+              <a:defRPr sz="1472"/>
             </a:lvl6pPr>
-            <a:lvl7pPr marL="2743200" indent="0" algn="ctr">
-              <a:buNone/>
-              <a:defRPr sz="1600"/>
+            <a:lvl7pPr marL="2523470" indent="0" algn="ctr">
+              <a:buNone/>
+              <a:defRPr sz="1472"/>
             </a:lvl7pPr>
-            <a:lvl8pPr marL="3200400" indent="0" algn="ctr">
-              <a:buNone/>
-              <a:defRPr sz="1600"/>
+            <a:lvl8pPr marL="2944048" indent="0" algn="ctr">
+              <a:buNone/>
+              <a:defRPr sz="1472"/>
             </a:lvl8pPr>
-            <a:lvl9pPr marL="3657600" indent="0" algn="ctr">
-              <a:buNone/>
-              <a:defRPr sz="1600"/>
+            <a:lvl9pPr marL="3364626" indent="0" algn="ctr">
+              <a:buNone/>
+              <a:defRPr sz="1472"/>
             </a:lvl9pPr>
           </a:lstStyle>
           <a:p>
@@ -245,9 +255,9 @@
           <a:bodyPr/>
           <a:lstStyle/>
           <a:p>
-            <a:fld id="{82737947-6FE8-42E1-A10A-88CBFF4FBA0B}" type="datetimeFigureOut">
+            <a:fld id="{9A446258-CCDE-4666-943B-74455BADD5F6}" type="datetimeFigureOut">
               <a:rPr lang="en-US" smtClean="0"/>
-              <a:t>9/15/2025</a:t>
+              <a:t>9/9/2026</a:t>
             </a:fld>
             <a:endParaRPr lang="en-US"/>
           </a:p>
@@ -287,7 +297,7 @@
           <a:bodyPr/>
           <a:lstStyle/>
           <a:p>
-            <a:fld id="{182F9092-2CF3-4F4B-B7E0-DE2F4CDB5A8C}" type="slidenum">
+            <a:fld id="{30FD5CD7-4071-4F69-BCB0-0A70623BA394}" type="slidenum">
               <a:rPr lang="en-US" smtClean="0"/>
               <a:t>‹#›</a:t>
             </a:fld>
@@ -298,16 +308,13 @@
     </p:spTree>
     <p:extLst>
       <p:ext uri="{BB962C8B-B14F-4D97-AF65-F5344CB8AC3E}">
-        <p14:creationId xmlns:p14="http://schemas.microsoft.com/office/powerpoint/2010/main" val="1494114163"/>
+        <p14:creationId xmlns:p14="http://schemas.microsoft.com/office/powerpoint/2010/main" val="1276409799"/>
       </p:ext>
     </p:extLst>
   </p:cSld>
   <p:clrMapOvr>
     <a:masterClrMapping/>
   </p:clrMapOvr>
-  <p:transition>
-    <p:push dir="u"/>
-  </p:transition>
 </p:sldLayout>
 </file>
 
@@ -418,9 +425,9 @@
           <a:bodyPr/>
           <a:lstStyle/>
           <a:p>
-            <a:fld id="{82737947-6FE8-42E1-A10A-88CBFF4FBA0B}" type="datetimeFigureOut">
+            <a:fld id="{9A446258-CCDE-4666-943B-74455BADD5F6}" type="datetimeFigureOut">
               <a:rPr lang="en-US" smtClean="0"/>
-              <a:t>9/15/2025</a:t>
+              <a:t>9/9/2026</a:t>
             </a:fld>
             <a:endParaRPr lang="en-US"/>
           </a:p>
@@ -460,7 +467,7 @@
           <a:bodyPr/>
           <a:lstStyle/>
           <a:p>
-            <a:fld id="{182F9092-2CF3-4F4B-B7E0-DE2F4CDB5A8C}" type="slidenum">
+            <a:fld id="{30FD5CD7-4071-4F69-BCB0-0A70623BA394}" type="slidenum">
               <a:rPr lang="en-US" smtClean="0"/>
               <a:t>‹#›</a:t>
             </a:fld>
@@ -471,16 +478,13 @@
     </p:spTree>
     <p:extLst>
       <p:ext uri="{BB962C8B-B14F-4D97-AF65-F5344CB8AC3E}">
-        <p14:creationId xmlns:p14="http://schemas.microsoft.com/office/powerpoint/2010/main" val="2309611382"/>
+        <p14:creationId xmlns:p14="http://schemas.microsoft.com/office/powerpoint/2010/main" val="719923238"/>
       </p:ext>
     </p:extLst>
   </p:cSld>
   <p:clrMapOvr>
     <a:masterClrMapping/>
   </p:clrMapOvr>
-  <p:transition>
-    <p:push dir="u"/>
-  </p:transition>
 </p:sldLayout>
 </file>
 
@@ -513,8 +517,8 @@
         </p:nvSpPr>
         <p:spPr>
           <a:xfrm>
-            <a:off x="6543675" y="365125"/>
-            <a:ext cx="1971675" cy="5811838"/>
+            <a:off x="6413030" y="335881"/>
+            <a:ext cx="1932310" cy="5346353"/>
           </a:xfrm>
         </p:spPr>
         <p:txBody>
@@ -541,8 +545,8 @@
         </p:nvSpPr>
         <p:spPr>
           <a:xfrm>
-            <a:off x="628650" y="365125"/>
-            <a:ext cx="5800725" cy="5811838"/>
+            <a:off x="616099" y="335881"/>
+            <a:ext cx="5684912" cy="5346353"/>
           </a:xfrm>
         </p:spPr>
         <p:txBody>
@@ -601,9 +605,9 @@
           <a:bodyPr/>
           <a:lstStyle/>
           <a:p>
-            <a:fld id="{82737947-6FE8-42E1-A10A-88CBFF4FBA0B}" type="datetimeFigureOut">
+            <a:fld id="{9A446258-CCDE-4666-943B-74455BADD5F6}" type="datetimeFigureOut">
               <a:rPr lang="en-US" smtClean="0"/>
-              <a:t>9/15/2025</a:t>
+              <a:t>9/9/2026</a:t>
             </a:fld>
             <a:endParaRPr lang="en-US"/>
           </a:p>
@@ -643,7 +647,7 @@
           <a:bodyPr/>
           <a:lstStyle/>
           <a:p>
-            <a:fld id="{182F9092-2CF3-4F4B-B7E0-DE2F4CDB5A8C}" type="slidenum">
+            <a:fld id="{30FD5CD7-4071-4F69-BCB0-0A70623BA394}" type="slidenum">
               <a:rPr lang="en-US" smtClean="0"/>
               <a:t>‹#›</a:t>
             </a:fld>
@@ -654,16 +658,13 @@
     </p:spTree>
     <p:extLst>
       <p:ext uri="{BB962C8B-B14F-4D97-AF65-F5344CB8AC3E}">
-        <p14:creationId xmlns:p14="http://schemas.microsoft.com/office/powerpoint/2010/main" val="2855380152"/>
+        <p14:creationId xmlns:p14="http://schemas.microsoft.com/office/powerpoint/2010/main" val="149739046"/>
       </p:ext>
     </p:extLst>
   </p:cSld>
   <p:clrMapOvr>
     <a:masterClrMapping/>
   </p:clrMapOvr>
-  <p:transition>
-    <p:push dir="u"/>
-  </p:transition>
 </p:sldLayout>
 </file>
 
@@ -774,9 +775,9 @@
           <a:bodyPr/>
           <a:lstStyle/>
           <a:p>
-            <a:fld id="{82737947-6FE8-42E1-A10A-88CBFF4FBA0B}" type="datetimeFigureOut">
+            <a:fld id="{9A446258-CCDE-4666-943B-74455BADD5F6}" type="datetimeFigureOut">
               <a:rPr lang="en-US" smtClean="0"/>
-              <a:t>9/15/2025</a:t>
+              <a:t>9/9/2026</a:t>
             </a:fld>
             <a:endParaRPr lang="en-US"/>
           </a:p>
@@ -816,7 +817,7 @@
           <a:bodyPr/>
           <a:lstStyle/>
           <a:p>
-            <a:fld id="{182F9092-2CF3-4F4B-B7E0-DE2F4CDB5A8C}" type="slidenum">
+            <a:fld id="{30FD5CD7-4071-4F69-BCB0-0A70623BA394}" type="slidenum">
               <a:rPr lang="en-US" smtClean="0"/>
               <a:t>‹#›</a:t>
             </a:fld>
@@ -827,16 +828,13 @@
     </p:spTree>
     <p:extLst>
       <p:ext uri="{BB962C8B-B14F-4D97-AF65-F5344CB8AC3E}">
-        <p14:creationId xmlns:p14="http://schemas.microsoft.com/office/powerpoint/2010/main" val="363596672"/>
+        <p14:creationId xmlns:p14="http://schemas.microsoft.com/office/powerpoint/2010/main" val="2205890345"/>
       </p:ext>
     </p:extLst>
   </p:cSld>
   <p:clrMapOvr>
     <a:masterClrMapping/>
   </p:clrMapOvr>
-  <p:transition>
-    <p:push dir="u"/>
-  </p:transition>
 </p:sldLayout>
 </file>
 
@@ -869,15 +867,15 @@
         </p:nvSpPr>
         <p:spPr>
           <a:xfrm>
-            <a:off x="623888" y="1709739"/>
-            <a:ext cx="7886700" cy="2852737"/>
+            <a:off x="611432" y="1572802"/>
+            <a:ext cx="7729240" cy="2624254"/>
           </a:xfrm>
         </p:spPr>
         <p:txBody>
           <a:bodyPr anchor="b"/>
           <a:lstStyle>
             <a:lvl1pPr>
-              <a:defRPr sz="6000"/>
+              <a:defRPr sz="5519"/>
             </a:lvl1pPr>
           </a:lstStyle>
           <a:p>
@@ -901,8 +899,8 @@
         </p:nvSpPr>
         <p:spPr>
           <a:xfrm>
-            <a:off x="623888" y="4589464"/>
-            <a:ext cx="7886700" cy="1500187"/>
+            <a:off x="611432" y="4221882"/>
+            <a:ext cx="7729240" cy="1380033"/>
           </a:xfrm>
         </p:spPr>
         <p:txBody>
@@ -910,15 +908,15 @@
           <a:lstStyle>
             <a:lvl1pPr marL="0" indent="0">
               <a:buNone/>
-              <a:defRPr sz="2400">
+              <a:defRPr sz="2208">
                 <a:solidFill>
                   <a:schemeClr val="tx1"/>
                 </a:solidFill>
               </a:defRPr>
             </a:lvl1pPr>
-            <a:lvl2pPr marL="457200" indent="0">
-              <a:buNone/>
-              <a:defRPr sz="2000">
+            <a:lvl2pPr marL="420578" indent="0">
+              <a:buNone/>
+              <a:defRPr sz="1840">
                 <a:solidFill>
                   <a:schemeClr val="tx1">
                     <a:tint val="75000"/>
@@ -926,9 +924,9 @@
                 </a:solidFill>
               </a:defRPr>
             </a:lvl2pPr>
-            <a:lvl3pPr marL="914400" indent="0">
-              <a:buNone/>
-              <a:defRPr sz="1800">
+            <a:lvl3pPr marL="841157" indent="0">
+              <a:buNone/>
+              <a:defRPr sz="1656">
                 <a:solidFill>
                   <a:schemeClr val="tx1">
                     <a:tint val="75000"/>
@@ -936,9 +934,9 @@
                 </a:solidFill>
               </a:defRPr>
             </a:lvl3pPr>
-            <a:lvl4pPr marL="1371600" indent="0">
-              <a:buNone/>
-              <a:defRPr sz="1600">
+            <a:lvl4pPr marL="1261735" indent="0">
+              <a:buNone/>
+              <a:defRPr sz="1472">
                 <a:solidFill>
                   <a:schemeClr val="tx1">
                     <a:tint val="75000"/>
@@ -946,9 +944,9 @@
                 </a:solidFill>
               </a:defRPr>
             </a:lvl4pPr>
-            <a:lvl5pPr marL="1828800" indent="0">
-              <a:buNone/>
-              <a:defRPr sz="1600">
+            <a:lvl5pPr marL="1682313" indent="0">
+              <a:buNone/>
+              <a:defRPr sz="1472">
                 <a:solidFill>
                   <a:schemeClr val="tx1">
                     <a:tint val="75000"/>
@@ -956,9 +954,9 @@
                 </a:solidFill>
               </a:defRPr>
             </a:lvl5pPr>
-            <a:lvl6pPr marL="2286000" indent="0">
-              <a:buNone/>
-              <a:defRPr sz="1600">
+            <a:lvl6pPr marL="2102891" indent="0">
+              <a:buNone/>
+              <a:defRPr sz="1472">
                 <a:solidFill>
                   <a:schemeClr val="tx1">
                     <a:tint val="75000"/>
@@ -966,9 +964,9 @@
                 </a:solidFill>
               </a:defRPr>
             </a:lvl6pPr>
-            <a:lvl7pPr marL="2743200" indent="0">
-              <a:buNone/>
-              <a:defRPr sz="1600">
+            <a:lvl7pPr marL="2523470" indent="0">
+              <a:buNone/>
+              <a:defRPr sz="1472">
                 <a:solidFill>
                   <a:schemeClr val="tx1">
                     <a:tint val="75000"/>
@@ -976,9 +974,9 @@
                 </a:solidFill>
               </a:defRPr>
             </a:lvl7pPr>
-            <a:lvl8pPr marL="3200400" indent="0">
-              <a:buNone/>
-              <a:defRPr sz="1600">
+            <a:lvl8pPr marL="2944048" indent="0">
+              <a:buNone/>
+              <a:defRPr sz="1472">
                 <a:solidFill>
                   <a:schemeClr val="tx1">
                     <a:tint val="75000"/>
@@ -986,9 +984,9 @@
                 </a:solidFill>
               </a:defRPr>
             </a:lvl8pPr>
-            <a:lvl9pPr marL="3657600" indent="0">
-              <a:buNone/>
-              <a:defRPr sz="1600">
+            <a:lvl9pPr marL="3364626" indent="0">
+              <a:buNone/>
+              <a:defRPr sz="1472">
                 <a:solidFill>
                   <a:schemeClr val="tx1">
                     <a:tint val="75000"/>
@@ -1021,9 +1019,9 @@
           <a:bodyPr/>
           <a:lstStyle/>
           <a:p>
-            <a:fld id="{82737947-6FE8-42E1-A10A-88CBFF4FBA0B}" type="datetimeFigureOut">
+            <a:fld id="{9A446258-CCDE-4666-943B-74455BADD5F6}" type="datetimeFigureOut">
               <a:rPr lang="en-US" smtClean="0"/>
-              <a:t>9/15/2025</a:t>
+              <a:t>9/9/2026</a:t>
             </a:fld>
             <a:endParaRPr lang="en-US"/>
           </a:p>
@@ -1063,7 +1061,7 @@
           <a:bodyPr/>
           <a:lstStyle/>
           <a:p>
-            <a:fld id="{182F9092-2CF3-4F4B-B7E0-DE2F4CDB5A8C}" type="slidenum">
+            <a:fld id="{30FD5CD7-4071-4F69-BCB0-0A70623BA394}" type="slidenum">
               <a:rPr lang="en-US" smtClean="0"/>
               <a:t>‹#›</a:t>
             </a:fld>
@@ -1074,16 +1072,13 @@
     </p:spTree>
     <p:extLst>
       <p:ext uri="{BB962C8B-B14F-4D97-AF65-F5344CB8AC3E}">
-        <p14:creationId xmlns:p14="http://schemas.microsoft.com/office/powerpoint/2010/main" val="1568737484"/>
+        <p14:creationId xmlns:p14="http://schemas.microsoft.com/office/powerpoint/2010/main" val="685386832"/>
       </p:ext>
     </p:extLst>
   </p:cSld>
   <p:clrMapOvr>
     <a:masterClrMapping/>
   </p:clrMapOvr>
-  <p:transition>
-    <p:push dir="u"/>
-  </p:transition>
 </p:sldLayout>
 </file>
 
@@ -1139,8 +1134,8 @@
         </p:nvSpPr>
         <p:spPr>
           <a:xfrm>
-            <a:off x="628650" y="1825625"/>
-            <a:ext cx="3886200" cy="4351338"/>
+            <a:off x="616099" y="1679406"/>
+            <a:ext cx="3808611" cy="4002828"/>
           </a:xfrm>
         </p:spPr>
         <p:txBody>
@@ -1196,8 +1191,8 @@
         </p:nvSpPr>
         <p:spPr>
           <a:xfrm>
-            <a:off x="4629150" y="1825625"/>
-            <a:ext cx="3886200" cy="4351338"/>
+            <a:off x="4536728" y="1679406"/>
+            <a:ext cx="3808611" cy="4002828"/>
           </a:xfrm>
         </p:spPr>
         <p:txBody>
@@ -1256,9 +1251,9 @@
           <a:bodyPr/>
           <a:lstStyle/>
           <a:p>
-            <a:fld id="{82737947-6FE8-42E1-A10A-88CBFF4FBA0B}" type="datetimeFigureOut">
+            <a:fld id="{9A446258-CCDE-4666-943B-74455BADD5F6}" type="datetimeFigureOut">
               <a:rPr lang="en-US" smtClean="0"/>
-              <a:t>9/15/2025</a:t>
+              <a:t>9/9/2026</a:t>
             </a:fld>
             <a:endParaRPr lang="en-US"/>
           </a:p>
@@ -1298,7 +1293,7 @@
           <a:bodyPr/>
           <a:lstStyle/>
           <a:p>
-            <a:fld id="{182F9092-2CF3-4F4B-B7E0-DE2F4CDB5A8C}" type="slidenum">
+            <a:fld id="{30FD5CD7-4071-4F69-BCB0-0A70623BA394}" type="slidenum">
               <a:rPr lang="en-US" smtClean="0"/>
               <a:t>‹#›</a:t>
             </a:fld>
@@ -1309,16 +1304,13 @@
     </p:spTree>
     <p:extLst>
       <p:ext uri="{BB962C8B-B14F-4D97-AF65-F5344CB8AC3E}">
-        <p14:creationId xmlns:p14="http://schemas.microsoft.com/office/powerpoint/2010/main" val="2802584947"/>
+        <p14:creationId xmlns:p14="http://schemas.microsoft.com/office/powerpoint/2010/main" val="3621628622"/>
       </p:ext>
     </p:extLst>
   </p:cSld>
   <p:clrMapOvr>
     <a:masterClrMapping/>
   </p:clrMapOvr>
-  <p:transition>
-    <p:push dir="u"/>
-  </p:transition>
 </p:sldLayout>
 </file>
 
@@ -1351,8 +1343,8 @@
         </p:nvSpPr>
         <p:spPr>
           <a:xfrm>
-            <a:off x="629841" y="365126"/>
-            <a:ext cx="7886700" cy="1325563"/>
+            <a:off x="617266" y="335883"/>
+            <a:ext cx="7729240" cy="1219395"/>
           </a:xfrm>
         </p:spPr>
         <p:txBody>
@@ -1379,8 +1371,8 @@
         </p:nvSpPr>
         <p:spPr>
           <a:xfrm>
-            <a:off x="629842" y="1681163"/>
-            <a:ext cx="3868340" cy="823912"/>
+            <a:off x="617267" y="1546514"/>
+            <a:ext cx="3791108" cy="757923"/>
           </a:xfrm>
         </p:spPr>
         <p:txBody>
@@ -1388,39 +1380,39 @@
           <a:lstStyle>
             <a:lvl1pPr marL="0" indent="0">
               <a:buNone/>
-              <a:defRPr sz="2400" b="1"/>
+              <a:defRPr sz="2208" b="1"/>
             </a:lvl1pPr>
-            <a:lvl2pPr marL="457200" indent="0">
-              <a:buNone/>
-              <a:defRPr sz="2000" b="1"/>
+            <a:lvl2pPr marL="420578" indent="0">
+              <a:buNone/>
+              <a:defRPr sz="1840" b="1"/>
             </a:lvl2pPr>
-            <a:lvl3pPr marL="914400" indent="0">
-              <a:buNone/>
-              <a:defRPr sz="1800" b="1"/>
+            <a:lvl3pPr marL="841157" indent="0">
+              <a:buNone/>
+              <a:defRPr sz="1656" b="1"/>
             </a:lvl3pPr>
-            <a:lvl4pPr marL="1371600" indent="0">
-              <a:buNone/>
-              <a:defRPr sz="1600" b="1"/>
+            <a:lvl4pPr marL="1261735" indent="0">
+              <a:buNone/>
+              <a:defRPr sz="1472" b="1"/>
             </a:lvl4pPr>
-            <a:lvl5pPr marL="1828800" indent="0">
-              <a:buNone/>
-              <a:defRPr sz="1600" b="1"/>
+            <a:lvl5pPr marL="1682313" indent="0">
+              <a:buNone/>
+              <a:defRPr sz="1472" b="1"/>
             </a:lvl5pPr>
-            <a:lvl6pPr marL="2286000" indent="0">
-              <a:buNone/>
-              <a:defRPr sz="1600" b="1"/>
+            <a:lvl6pPr marL="2102891" indent="0">
+              <a:buNone/>
+              <a:defRPr sz="1472" b="1"/>
             </a:lvl6pPr>
-            <a:lvl7pPr marL="2743200" indent="0">
-              <a:buNone/>
-              <a:defRPr sz="1600" b="1"/>
+            <a:lvl7pPr marL="2523470" indent="0">
+              <a:buNone/>
+              <a:defRPr sz="1472" b="1"/>
             </a:lvl7pPr>
-            <a:lvl8pPr marL="3200400" indent="0">
-              <a:buNone/>
-              <a:defRPr sz="1600" b="1"/>
+            <a:lvl8pPr marL="2944048" indent="0">
+              <a:buNone/>
+              <a:defRPr sz="1472" b="1"/>
             </a:lvl8pPr>
-            <a:lvl9pPr marL="3657600" indent="0">
-              <a:buNone/>
-              <a:defRPr sz="1600" b="1"/>
+            <a:lvl9pPr marL="3364626" indent="0">
+              <a:buNone/>
+              <a:defRPr sz="1472" b="1"/>
             </a:lvl9pPr>
           </a:lstStyle>
           <a:p>
@@ -1444,8 +1436,8 @@
         </p:nvSpPr>
         <p:spPr>
           <a:xfrm>
-            <a:off x="629842" y="2505075"/>
-            <a:ext cx="3868340" cy="3684588"/>
+            <a:off x="617267" y="2304437"/>
+            <a:ext cx="3791108" cy="3389480"/>
           </a:xfrm>
         </p:spPr>
         <p:txBody>
@@ -1501,8 +1493,8 @@
         </p:nvSpPr>
         <p:spPr>
           <a:xfrm>
-            <a:off x="4629150" y="1681163"/>
-            <a:ext cx="3887391" cy="823912"/>
+            <a:off x="4536729" y="1546514"/>
+            <a:ext cx="3809778" cy="757923"/>
           </a:xfrm>
         </p:spPr>
         <p:txBody>
@@ -1510,39 +1502,39 @@
           <a:lstStyle>
             <a:lvl1pPr marL="0" indent="0">
               <a:buNone/>
-              <a:defRPr sz="2400" b="1"/>
+              <a:defRPr sz="2208" b="1"/>
             </a:lvl1pPr>
-            <a:lvl2pPr marL="457200" indent="0">
-              <a:buNone/>
-              <a:defRPr sz="2000" b="1"/>
+            <a:lvl2pPr marL="420578" indent="0">
+              <a:buNone/>
+              <a:defRPr sz="1840" b="1"/>
             </a:lvl2pPr>
-            <a:lvl3pPr marL="914400" indent="0">
-              <a:buNone/>
-              <a:defRPr sz="1800" b="1"/>
+            <a:lvl3pPr marL="841157" indent="0">
+              <a:buNone/>
+              <a:defRPr sz="1656" b="1"/>
             </a:lvl3pPr>
-            <a:lvl4pPr marL="1371600" indent="0">
-              <a:buNone/>
-              <a:defRPr sz="1600" b="1"/>
+            <a:lvl4pPr marL="1261735" indent="0">
+              <a:buNone/>
+              <a:defRPr sz="1472" b="1"/>
             </a:lvl4pPr>
-            <a:lvl5pPr marL="1828800" indent="0">
-              <a:buNone/>
-              <a:defRPr sz="1600" b="1"/>
+            <a:lvl5pPr marL="1682313" indent="0">
+              <a:buNone/>
+              <a:defRPr sz="1472" b="1"/>
             </a:lvl5pPr>
-            <a:lvl6pPr marL="2286000" indent="0">
-              <a:buNone/>
-              <a:defRPr sz="1600" b="1"/>
+            <a:lvl6pPr marL="2102891" indent="0">
+              <a:buNone/>
+              <a:defRPr sz="1472" b="1"/>
             </a:lvl6pPr>
-            <a:lvl7pPr marL="2743200" indent="0">
-              <a:buNone/>
-              <a:defRPr sz="1600" b="1"/>
+            <a:lvl7pPr marL="2523470" indent="0">
+              <a:buNone/>
+              <a:defRPr sz="1472" b="1"/>
             </a:lvl7pPr>
-            <a:lvl8pPr marL="3200400" indent="0">
-              <a:buNone/>
-              <a:defRPr sz="1600" b="1"/>
+            <a:lvl8pPr marL="2944048" indent="0">
+              <a:buNone/>
+              <a:defRPr sz="1472" b="1"/>
             </a:lvl8pPr>
-            <a:lvl9pPr marL="3657600" indent="0">
-              <a:buNone/>
-              <a:defRPr sz="1600" b="1"/>
+            <a:lvl9pPr marL="3364626" indent="0">
+              <a:buNone/>
+              <a:defRPr sz="1472" b="1"/>
             </a:lvl9pPr>
           </a:lstStyle>
           <a:p>
@@ -1566,8 +1558,8 @@
         </p:nvSpPr>
         <p:spPr>
           <a:xfrm>
-            <a:off x="4629150" y="2505075"/>
-            <a:ext cx="3887391" cy="3684588"/>
+            <a:off x="4536729" y="2304437"/>
+            <a:ext cx="3809778" cy="3389480"/>
           </a:xfrm>
         </p:spPr>
         <p:txBody>
@@ -1626,9 +1618,9 @@
           <a:bodyPr/>
           <a:lstStyle/>
           <a:p>
-            <a:fld id="{82737947-6FE8-42E1-A10A-88CBFF4FBA0B}" type="datetimeFigureOut">
+            <a:fld id="{9A446258-CCDE-4666-943B-74455BADD5F6}" type="datetimeFigureOut">
               <a:rPr lang="en-US" smtClean="0"/>
-              <a:t>9/15/2025</a:t>
+              <a:t>9/9/2026</a:t>
             </a:fld>
             <a:endParaRPr lang="en-US"/>
           </a:p>
@@ -1668,7 +1660,7 @@
           <a:bodyPr/>
           <a:lstStyle/>
           <a:p>
-            <a:fld id="{182F9092-2CF3-4F4B-B7E0-DE2F4CDB5A8C}" type="slidenum">
+            <a:fld id="{30FD5CD7-4071-4F69-BCB0-0A70623BA394}" type="slidenum">
               <a:rPr lang="en-US" smtClean="0"/>
               <a:t>‹#›</a:t>
             </a:fld>
@@ -1679,16 +1671,13 @@
     </p:spTree>
     <p:extLst>
       <p:ext uri="{BB962C8B-B14F-4D97-AF65-F5344CB8AC3E}">
-        <p14:creationId xmlns:p14="http://schemas.microsoft.com/office/powerpoint/2010/main" val="4185290497"/>
+        <p14:creationId xmlns:p14="http://schemas.microsoft.com/office/powerpoint/2010/main" val="1071060357"/>
       </p:ext>
     </p:extLst>
   </p:cSld>
   <p:clrMapOvr>
     <a:masterClrMapping/>
   </p:clrMapOvr>
-  <p:transition>
-    <p:push dir="u"/>
-  </p:transition>
 </p:sldLayout>
 </file>
 
@@ -1747,9 +1736,9 @@
           <a:bodyPr/>
           <a:lstStyle/>
           <a:p>
-            <a:fld id="{82737947-6FE8-42E1-A10A-88CBFF4FBA0B}" type="datetimeFigureOut">
+            <a:fld id="{9A446258-CCDE-4666-943B-74455BADD5F6}" type="datetimeFigureOut">
               <a:rPr lang="en-US" smtClean="0"/>
-              <a:t>9/15/2025</a:t>
+              <a:t>9/9/2026</a:t>
             </a:fld>
             <a:endParaRPr lang="en-US"/>
           </a:p>
@@ -1789,7 +1778,7 @@
           <a:bodyPr/>
           <a:lstStyle/>
           <a:p>
-            <a:fld id="{182F9092-2CF3-4F4B-B7E0-DE2F4CDB5A8C}" type="slidenum">
+            <a:fld id="{30FD5CD7-4071-4F69-BCB0-0A70623BA394}" type="slidenum">
               <a:rPr lang="en-US" smtClean="0"/>
               <a:t>‹#›</a:t>
             </a:fld>
@@ -1800,16 +1789,13 @@
     </p:spTree>
     <p:extLst>
       <p:ext uri="{BB962C8B-B14F-4D97-AF65-F5344CB8AC3E}">
-        <p14:creationId xmlns:p14="http://schemas.microsoft.com/office/powerpoint/2010/main" val="2192005151"/>
+        <p14:creationId xmlns:p14="http://schemas.microsoft.com/office/powerpoint/2010/main" val="2153272671"/>
       </p:ext>
     </p:extLst>
   </p:cSld>
   <p:clrMapOvr>
     <a:masterClrMapping/>
   </p:clrMapOvr>
-  <p:transition>
-    <p:push dir="u"/>
-  </p:transition>
 </p:sldLayout>
 </file>
 
@@ -1845,9 +1831,9 @@
           <a:bodyPr/>
           <a:lstStyle/>
           <a:p>
-            <a:fld id="{82737947-6FE8-42E1-A10A-88CBFF4FBA0B}" type="datetimeFigureOut">
+            <a:fld id="{9A446258-CCDE-4666-943B-74455BADD5F6}" type="datetimeFigureOut">
               <a:rPr lang="en-US" smtClean="0"/>
-              <a:t>9/15/2025</a:t>
+              <a:t>9/9/2026</a:t>
             </a:fld>
             <a:endParaRPr lang="en-US"/>
           </a:p>
@@ -1887,7 +1873,7 @@
           <a:bodyPr/>
           <a:lstStyle/>
           <a:p>
-            <a:fld id="{182F9092-2CF3-4F4B-B7E0-DE2F4CDB5A8C}" type="slidenum">
+            <a:fld id="{30FD5CD7-4071-4F69-BCB0-0A70623BA394}" type="slidenum">
               <a:rPr lang="en-US" smtClean="0"/>
               <a:t>‹#›</a:t>
             </a:fld>
@@ -1898,16 +1884,13 @@
     </p:spTree>
     <p:extLst>
       <p:ext uri="{BB962C8B-B14F-4D97-AF65-F5344CB8AC3E}">
-        <p14:creationId xmlns:p14="http://schemas.microsoft.com/office/powerpoint/2010/main" val="1861912139"/>
+        <p14:creationId xmlns:p14="http://schemas.microsoft.com/office/powerpoint/2010/main" val="153558893"/>
       </p:ext>
     </p:extLst>
   </p:cSld>
   <p:clrMapOvr>
     <a:masterClrMapping/>
   </p:clrMapOvr>
-  <p:transition>
-    <p:push dir="u"/>
-  </p:transition>
 </p:sldLayout>
 </file>
 
@@ -1940,15 +1923,15 @@
         </p:nvSpPr>
         <p:spPr>
           <a:xfrm>
-            <a:off x="629841" y="457200"/>
-            <a:ext cx="2949178" cy="1600200"/>
+            <a:off x="617266" y="420582"/>
+            <a:ext cx="2890297" cy="1472036"/>
           </a:xfrm>
         </p:spPr>
         <p:txBody>
           <a:bodyPr anchor="b"/>
           <a:lstStyle>
             <a:lvl1pPr>
-              <a:defRPr sz="3200"/>
+              <a:defRPr sz="2944"/>
             </a:lvl1pPr>
           </a:lstStyle>
           <a:p>
@@ -1972,39 +1955,39 @@
         </p:nvSpPr>
         <p:spPr>
           <a:xfrm>
-            <a:off x="3887391" y="987426"/>
-            <a:ext cx="4629150" cy="4873625"/>
+            <a:off x="3809778" y="908341"/>
+            <a:ext cx="4536728" cy="4483284"/>
           </a:xfrm>
         </p:spPr>
         <p:txBody>
           <a:bodyPr/>
           <a:lstStyle>
             <a:lvl1pPr>
-              <a:defRPr sz="3200"/>
+              <a:defRPr sz="2944"/>
             </a:lvl1pPr>
             <a:lvl2pPr>
-              <a:defRPr sz="2800"/>
+              <a:defRPr sz="2576"/>
             </a:lvl2pPr>
             <a:lvl3pPr>
-              <a:defRPr sz="2400"/>
+              <a:defRPr sz="2208"/>
             </a:lvl3pPr>
             <a:lvl4pPr>
-              <a:defRPr sz="2000"/>
+              <a:defRPr sz="1840"/>
             </a:lvl4pPr>
             <a:lvl5pPr>
-              <a:defRPr sz="2000"/>
+              <a:defRPr sz="1840"/>
             </a:lvl5pPr>
             <a:lvl6pPr>
-              <a:defRPr sz="2000"/>
+              <a:defRPr sz="1840"/>
             </a:lvl6pPr>
             <a:lvl7pPr>
-              <a:defRPr sz="2000"/>
+              <a:defRPr sz="1840"/>
             </a:lvl7pPr>
             <a:lvl8pPr>
-              <a:defRPr sz="2000"/>
+              <a:defRPr sz="1840"/>
             </a:lvl8pPr>
             <a:lvl9pPr>
-              <a:defRPr sz="2000"/>
+              <a:defRPr sz="1840"/>
             </a:lvl9pPr>
           </a:lstStyle>
           <a:p>
@@ -2057,8 +2040,8 @@
         </p:nvSpPr>
         <p:spPr>
           <a:xfrm>
-            <a:off x="629841" y="2057400"/>
-            <a:ext cx="2949178" cy="3811588"/>
+            <a:off x="617266" y="1892618"/>
+            <a:ext cx="2890297" cy="3506308"/>
           </a:xfrm>
         </p:spPr>
         <p:txBody>
@@ -2066,39 +2049,39 @@
           <a:lstStyle>
             <a:lvl1pPr marL="0" indent="0">
               <a:buNone/>
-              <a:defRPr sz="1600"/>
+              <a:defRPr sz="1472"/>
             </a:lvl1pPr>
-            <a:lvl2pPr marL="457200" indent="0">
-              <a:buNone/>
-              <a:defRPr sz="1400"/>
+            <a:lvl2pPr marL="420578" indent="0">
+              <a:buNone/>
+              <a:defRPr sz="1288"/>
             </a:lvl2pPr>
-            <a:lvl3pPr marL="914400" indent="0">
-              <a:buNone/>
-              <a:defRPr sz="1200"/>
+            <a:lvl3pPr marL="841157" indent="0">
+              <a:buNone/>
+              <a:defRPr sz="1104"/>
             </a:lvl3pPr>
-            <a:lvl4pPr marL="1371600" indent="0">
-              <a:buNone/>
-              <a:defRPr sz="1000"/>
+            <a:lvl4pPr marL="1261735" indent="0">
+              <a:buNone/>
+              <a:defRPr sz="920"/>
             </a:lvl4pPr>
-            <a:lvl5pPr marL="1828800" indent="0">
-              <a:buNone/>
-              <a:defRPr sz="1000"/>
+            <a:lvl5pPr marL="1682313" indent="0">
+              <a:buNone/>
+              <a:defRPr sz="920"/>
             </a:lvl5pPr>
-            <a:lvl6pPr marL="2286000" indent="0">
-              <a:buNone/>
-              <a:defRPr sz="1000"/>
+            <a:lvl6pPr marL="2102891" indent="0">
+              <a:buNone/>
+              <a:defRPr sz="920"/>
             </a:lvl6pPr>
-            <a:lvl7pPr marL="2743200" indent="0">
-              <a:buNone/>
-              <a:defRPr sz="1000"/>
+            <a:lvl7pPr marL="2523470" indent="0">
+              <a:buNone/>
+              <a:defRPr sz="920"/>
             </a:lvl7pPr>
-            <a:lvl8pPr marL="3200400" indent="0">
-              <a:buNone/>
-              <a:defRPr sz="1000"/>
+            <a:lvl8pPr marL="2944048" indent="0">
+              <a:buNone/>
+              <a:defRPr sz="920"/>
             </a:lvl8pPr>
-            <a:lvl9pPr marL="3657600" indent="0">
-              <a:buNone/>
-              <a:defRPr sz="1000"/>
+            <a:lvl9pPr marL="3364626" indent="0">
+              <a:buNone/>
+              <a:defRPr sz="920"/>
             </a:lvl9pPr>
           </a:lstStyle>
           <a:p>
@@ -2125,9 +2108,9 @@
           <a:bodyPr/>
           <a:lstStyle/>
           <a:p>
-            <a:fld id="{82737947-6FE8-42E1-A10A-88CBFF4FBA0B}" type="datetimeFigureOut">
+            <a:fld id="{9A446258-CCDE-4666-943B-74455BADD5F6}" type="datetimeFigureOut">
               <a:rPr lang="en-US" smtClean="0"/>
-              <a:t>9/15/2025</a:t>
+              <a:t>9/9/2026</a:t>
             </a:fld>
             <a:endParaRPr lang="en-US"/>
           </a:p>
@@ -2167,7 +2150,7 @@
           <a:bodyPr/>
           <a:lstStyle/>
           <a:p>
-            <a:fld id="{182F9092-2CF3-4F4B-B7E0-DE2F4CDB5A8C}" type="slidenum">
+            <a:fld id="{30FD5CD7-4071-4F69-BCB0-0A70623BA394}" type="slidenum">
               <a:rPr lang="en-US" smtClean="0"/>
               <a:t>‹#›</a:t>
             </a:fld>
@@ -2178,16 +2161,13 @@
     </p:spTree>
     <p:extLst>
       <p:ext uri="{BB962C8B-B14F-4D97-AF65-F5344CB8AC3E}">
-        <p14:creationId xmlns:p14="http://schemas.microsoft.com/office/powerpoint/2010/main" val="3840672068"/>
+        <p14:creationId xmlns:p14="http://schemas.microsoft.com/office/powerpoint/2010/main" val="4084446749"/>
       </p:ext>
     </p:extLst>
   </p:cSld>
   <p:clrMapOvr>
     <a:masterClrMapping/>
   </p:clrMapOvr>
-  <p:transition>
-    <p:push dir="u"/>
-  </p:transition>
 </p:sldLayout>
 </file>
 
@@ -2220,15 +2200,15 @@
         </p:nvSpPr>
         <p:spPr>
           <a:xfrm>
-            <a:off x="629841" y="457200"/>
-            <a:ext cx="2949178" cy="1600200"/>
+            <a:off x="617266" y="420582"/>
+            <a:ext cx="2890297" cy="1472036"/>
           </a:xfrm>
         </p:spPr>
         <p:txBody>
           <a:bodyPr anchor="b"/>
           <a:lstStyle>
             <a:lvl1pPr>
-              <a:defRPr sz="3200"/>
+              <a:defRPr sz="2944"/>
             </a:lvl1pPr>
           </a:lstStyle>
           <a:p>
@@ -2252,8 +2232,8 @@
         </p:nvSpPr>
         <p:spPr>
           <a:xfrm>
-            <a:off x="3887391" y="987426"/>
-            <a:ext cx="4629150" cy="4873625"/>
+            <a:off x="3809778" y="908341"/>
+            <a:ext cx="4536728" cy="4483284"/>
           </a:xfrm>
         </p:spPr>
         <p:txBody>
@@ -2261,39 +2241,39 @@
           <a:lstStyle>
             <a:lvl1pPr marL="0" indent="0">
               <a:buNone/>
-              <a:defRPr sz="3200"/>
+              <a:defRPr sz="2944"/>
             </a:lvl1pPr>
-            <a:lvl2pPr marL="457200" indent="0">
-              <a:buNone/>
-              <a:defRPr sz="2800"/>
+            <a:lvl2pPr marL="420578" indent="0">
+              <a:buNone/>
+              <a:defRPr sz="2576"/>
             </a:lvl2pPr>
-            <a:lvl3pPr marL="914400" indent="0">
-              <a:buNone/>
-              <a:defRPr sz="2400"/>
+            <a:lvl3pPr marL="841157" indent="0">
+              <a:buNone/>
+              <a:defRPr sz="2208"/>
             </a:lvl3pPr>
-            <a:lvl4pPr marL="1371600" indent="0">
-              <a:buNone/>
-              <a:defRPr sz="2000"/>
+            <a:lvl4pPr marL="1261735" indent="0">
+              <a:buNone/>
+              <a:defRPr sz="1840"/>
             </a:lvl4pPr>
-            <a:lvl5pPr marL="1828800" indent="0">
-              <a:buNone/>
-              <a:defRPr sz="2000"/>
+            <a:lvl5pPr marL="1682313" indent="0">
+              <a:buNone/>
+              <a:defRPr sz="1840"/>
             </a:lvl5pPr>
-            <a:lvl6pPr marL="2286000" indent="0">
-              <a:buNone/>
-              <a:defRPr sz="2000"/>
+            <a:lvl6pPr marL="2102891" indent="0">
+              <a:buNone/>
+              <a:defRPr sz="1840"/>
             </a:lvl6pPr>
-            <a:lvl7pPr marL="2743200" indent="0">
-              <a:buNone/>
-              <a:defRPr sz="2000"/>
+            <a:lvl7pPr marL="2523470" indent="0">
+              <a:buNone/>
+              <a:defRPr sz="1840"/>
             </a:lvl7pPr>
-            <a:lvl8pPr marL="3200400" indent="0">
-              <a:buNone/>
-              <a:defRPr sz="2000"/>
+            <a:lvl8pPr marL="2944048" indent="0">
+              <a:buNone/>
+              <a:defRPr sz="1840"/>
             </a:lvl8pPr>
-            <a:lvl9pPr marL="3657600" indent="0">
-              <a:buNone/>
-              <a:defRPr sz="2000"/>
+            <a:lvl9pPr marL="3364626" indent="0">
+              <a:buNone/>
+              <a:defRPr sz="1840"/>
             </a:lvl9pPr>
           </a:lstStyle>
           <a:p>
@@ -2317,8 +2297,8 @@
         </p:nvSpPr>
         <p:spPr>
           <a:xfrm>
-            <a:off x="629841" y="2057400"/>
-            <a:ext cx="2949178" cy="3811588"/>
+            <a:off x="617266" y="1892618"/>
+            <a:ext cx="2890297" cy="3506308"/>
           </a:xfrm>
         </p:spPr>
         <p:txBody>
@@ -2326,39 +2306,39 @@
           <a:lstStyle>
             <a:lvl1pPr marL="0" indent="0">
               <a:buNone/>
-              <a:defRPr sz="1600"/>
+              <a:defRPr sz="1472"/>
             </a:lvl1pPr>
-            <a:lvl2pPr marL="457200" indent="0">
-              <a:buNone/>
-              <a:defRPr sz="1400"/>
+            <a:lvl2pPr marL="420578" indent="0">
+              <a:buNone/>
+              <a:defRPr sz="1288"/>
             </a:lvl2pPr>
-            <a:lvl3pPr marL="914400" indent="0">
-              <a:buNone/>
-              <a:defRPr sz="1200"/>
+            <a:lvl3pPr marL="841157" indent="0">
+              <a:buNone/>
+              <a:defRPr sz="1104"/>
             </a:lvl3pPr>
-            <a:lvl4pPr marL="1371600" indent="0">
-              <a:buNone/>
-              <a:defRPr sz="1000"/>
+            <a:lvl4pPr marL="1261735" indent="0">
+              <a:buNone/>
+              <a:defRPr sz="920"/>
             </a:lvl4pPr>
-            <a:lvl5pPr marL="1828800" indent="0">
-              <a:buNone/>
-              <a:defRPr sz="1000"/>
+            <a:lvl5pPr marL="1682313" indent="0">
+              <a:buNone/>
+              <a:defRPr sz="920"/>
             </a:lvl5pPr>
-            <a:lvl6pPr marL="2286000" indent="0">
-              <a:buNone/>
-              <a:defRPr sz="1000"/>
+            <a:lvl6pPr marL="2102891" indent="0">
+              <a:buNone/>
+              <a:defRPr sz="920"/>
             </a:lvl6pPr>
-            <a:lvl7pPr marL="2743200" indent="0">
-              <a:buNone/>
-              <a:defRPr sz="1000"/>
+            <a:lvl7pPr marL="2523470" indent="0">
+              <a:buNone/>
+              <a:defRPr sz="920"/>
             </a:lvl7pPr>
-            <a:lvl8pPr marL="3200400" indent="0">
-              <a:buNone/>
-              <a:defRPr sz="1000"/>
+            <a:lvl8pPr marL="2944048" indent="0">
+              <a:buNone/>
+              <a:defRPr sz="920"/>
             </a:lvl8pPr>
-            <a:lvl9pPr marL="3657600" indent="0">
-              <a:buNone/>
-              <a:defRPr sz="1000"/>
+            <a:lvl9pPr marL="3364626" indent="0">
+              <a:buNone/>
+              <a:defRPr sz="920"/>
             </a:lvl9pPr>
           </a:lstStyle>
           <a:p>
@@ -2385,9 +2365,9 @@
           <a:bodyPr/>
           <a:lstStyle/>
           <a:p>
-            <a:fld id="{82737947-6FE8-42E1-A10A-88CBFF4FBA0B}" type="datetimeFigureOut">
+            <a:fld id="{9A446258-CCDE-4666-943B-74455BADD5F6}" type="datetimeFigureOut">
               <a:rPr lang="en-US" smtClean="0"/>
-              <a:t>9/15/2025</a:t>
+              <a:t>9/9/2026</a:t>
             </a:fld>
             <a:endParaRPr lang="en-US"/>
           </a:p>
@@ -2427,7 +2407,7 @@
           <a:bodyPr/>
           <a:lstStyle/>
           <a:p>
-            <a:fld id="{182F9092-2CF3-4F4B-B7E0-DE2F4CDB5A8C}" type="slidenum">
+            <a:fld id="{30FD5CD7-4071-4F69-BCB0-0A70623BA394}" type="slidenum">
               <a:rPr lang="en-US" smtClean="0"/>
               <a:t>‹#›</a:t>
             </a:fld>
@@ -2438,16 +2418,13 @@
     </p:spTree>
     <p:extLst>
       <p:ext uri="{BB962C8B-B14F-4D97-AF65-F5344CB8AC3E}">
-        <p14:creationId xmlns:p14="http://schemas.microsoft.com/office/powerpoint/2010/main" val="3721527645"/>
+        <p14:creationId xmlns:p14="http://schemas.microsoft.com/office/powerpoint/2010/main" val="475242110"/>
       </p:ext>
     </p:extLst>
   </p:cSld>
   <p:clrMapOvr>
     <a:masterClrMapping/>
   </p:clrMapOvr>
-  <p:transition>
-    <p:push dir="u"/>
-  </p:transition>
 </p:sldLayout>
 </file>
 
@@ -2455,12 +2432,9 @@
 <p:sldMaster xmlns:a="http://schemas.openxmlformats.org/drawingml/2006/main" xmlns:r="http://schemas.openxmlformats.org/officeDocument/2006/relationships" xmlns:p="http://schemas.openxmlformats.org/presentationml/2006/main">
   <p:cSld>
     <p:bg>
-      <p:bgPr>
-        <a:solidFill>
-          <a:srgbClr val="FCEBD7"/>
-        </a:solidFill>
-        <a:effectLst/>
-      </p:bgPr>
+      <p:bgRef idx="1001">
+        <a:schemeClr val="bg1"/>
+      </p:bgRef>
     </p:bg>
     <p:spTree>
       <p:nvGrpSpPr>
@@ -2488,8 +2462,8 @@
         </p:nvSpPr>
         <p:spPr>
           <a:xfrm>
-            <a:off x="628650" y="365126"/>
-            <a:ext cx="7886700" cy="1325563"/>
+            <a:off x="616099" y="335883"/>
+            <a:ext cx="7729240" cy="1219395"/>
           </a:xfrm>
           <a:prstGeom prst="rect">
             <a:avLst/>
@@ -2521,8 +2495,8 @@
         </p:nvSpPr>
         <p:spPr>
           <a:xfrm>
-            <a:off x="628650" y="1825625"/>
-            <a:ext cx="7886700" cy="4351338"/>
+            <a:off x="616099" y="1679406"/>
+            <a:ext cx="7729240" cy="4002828"/>
           </a:xfrm>
           <a:prstGeom prst="rect">
             <a:avLst/>
@@ -2583,8 +2557,8 @@
         </p:nvSpPr>
         <p:spPr>
           <a:xfrm>
-            <a:off x="628650" y="6356351"/>
-            <a:ext cx="2057400" cy="365125"/>
+            <a:off x="616099" y="5847255"/>
+            <a:ext cx="2016324" cy="335881"/>
           </a:xfrm>
           <a:prstGeom prst="rect">
             <a:avLst/>
@@ -2594,7 +2568,7 @@
           <a:bodyPr vert="horz" lIns="91440" tIns="45720" rIns="91440" bIns="45720" rtlCol="0" anchor="ctr"/>
           <a:lstStyle>
             <a:lvl1pPr algn="l">
-              <a:defRPr sz="1200">
+              <a:defRPr sz="1104">
                 <a:solidFill>
                   <a:schemeClr val="tx1">
                     <a:tint val="75000"/>
@@ -2604,9 +2578,9 @@
             </a:lvl1pPr>
           </a:lstStyle>
           <a:p>
-            <a:fld id="{82737947-6FE8-42E1-A10A-88CBFF4FBA0B}" type="datetimeFigureOut">
+            <a:fld id="{9A446258-CCDE-4666-943B-74455BADD5F6}" type="datetimeFigureOut">
               <a:rPr lang="en-US" smtClean="0"/>
-              <a:t>9/15/2025</a:t>
+              <a:t>9/9/2026</a:t>
             </a:fld>
             <a:endParaRPr lang="en-US"/>
           </a:p>
@@ -2624,8 +2598,8 @@
         </p:nvSpPr>
         <p:spPr>
           <a:xfrm>
-            <a:off x="3028950" y="6356351"/>
-            <a:ext cx="3086100" cy="365125"/>
+            <a:off x="2968477" y="5847255"/>
+            <a:ext cx="3024485" cy="335881"/>
           </a:xfrm>
           <a:prstGeom prst="rect">
             <a:avLst/>
@@ -2635,7 +2609,7 @@
           <a:bodyPr vert="horz" lIns="91440" tIns="45720" rIns="91440" bIns="45720" rtlCol="0" anchor="ctr"/>
           <a:lstStyle>
             <a:lvl1pPr algn="ctr">
-              <a:defRPr sz="1200">
+              <a:defRPr sz="1104">
                 <a:solidFill>
                   <a:schemeClr val="tx1">
                     <a:tint val="75000"/>
@@ -2661,8 +2635,8 @@
         </p:nvSpPr>
         <p:spPr>
           <a:xfrm>
-            <a:off x="6457950" y="6356351"/>
-            <a:ext cx="2057400" cy="365125"/>
+            <a:off x="6329015" y="5847255"/>
+            <a:ext cx="2016324" cy="335881"/>
           </a:xfrm>
           <a:prstGeom prst="rect">
             <a:avLst/>
@@ -2672,7 +2646,7 @@
           <a:bodyPr vert="horz" lIns="91440" tIns="45720" rIns="91440" bIns="45720" rtlCol="0" anchor="ctr"/>
           <a:lstStyle>
             <a:lvl1pPr algn="r">
-              <a:defRPr sz="1200">
+              <a:defRPr sz="1104">
                 <a:solidFill>
                   <a:schemeClr val="tx1">
                     <a:tint val="75000"/>
@@ -2682,7 +2656,7 @@
             </a:lvl1pPr>
           </a:lstStyle>
           <a:p>
-            <a:fld id="{182F9092-2CF3-4F4B-B7E0-DE2F4CDB5A8C}" type="slidenum">
+            <a:fld id="{30FD5CD7-4071-4F69-BCB0-0A70623BA394}" type="slidenum">
               <a:rPr lang="en-US" smtClean="0"/>
               <a:t>‹#›</a:t>
             </a:fld>
@@ -2693,30 +2667,27 @@
     </p:spTree>
     <p:extLst>
       <p:ext uri="{BB962C8B-B14F-4D97-AF65-F5344CB8AC3E}">
-        <p14:creationId xmlns:p14="http://schemas.microsoft.com/office/powerpoint/2010/main" val="2942255104"/>
+        <p14:creationId xmlns:p14="http://schemas.microsoft.com/office/powerpoint/2010/main" val="156757303"/>
       </p:ext>
     </p:extLst>
   </p:cSld>
   <p:clrMap bg1="lt1" tx1="dk1" bg2="lt2" tx2="dk2" accent1="accent1" accent2="accent2" accent3="accent3" accent4="accent4" accent5="accent5" accent6="accent6" hlink="hlink" folHlink="folHlink"/>
   <p:sldLayoutIdLst>
-    <p:sldLayoutId id="2147483661" r:id="rId1"/>
-    <p:sldLayoutId id="2147483662" r:id="rId2"/>
-    <p:sldLayoutId id="2147483663" r:id="rId3"/>
-    <p:sldLayoutId id="2147483664" r:id="rId4"/>
-    <p:sldLayoutId id="2147483665" r:id="rId5"/>
-    <p:sldLayoutId id="2147483666" r:id="rId6"/>
-    <p:sldLayoutId id="2147483667" r:id="rId7"/>
-    <p:sldLayoutId id="2147483668" r:id="rId8"/>
-    <p:sldLayoutId id="2147483669" r:id="rId9"/>
-    <p:sldLayoutId id="2147483670" r:id="rId10"/>
-    <p:sldLayoutId id="2147483671" r:id="rId11"/>
+    <p:sldLayoutId id="2147483697" r:id="rId1"/>
+    <p:sldLayoutId id="2147483698" r:id="rId2"/>
+    <p:sldLayoutId id="2147483699" r:id="rId3"/>
+    <p:sldLayoutId id="2147483700" r:id="rId4"/>
+    <p:sldLayoutId id="2147483701" r:id="rId5"/>
+    <p:sldLayoutId id="2147483702" r:id="rId6"/>
+    <p:sldLayoutId id="2147483703" r:id="rId7"/>
+    <p:sldLayoutId id="2147483704" r:id="rId8"/>
+    <p:sldLayoutId id="2147483705" r:id="rId9"/>
+    <p:sldLayoutId id="2147483706" r:id="rId10"/>
+    <p:sldLayoutId id="2147483707" r:id="rId11"/>
   </p:sldLayoutIdLst>
-  <p:transition>
-    <p:push dir="u"/>
-  </p:transition>
   <p:txStyles>
     <p:titleStyle>
-      <a:lvl1pPr algn="l" defTabSz="914400" rtl="0" eaLnBrk="1" latinLnBrk="0" hangingPunct="1">
+      <a:lvl1pPr algn="l" defTabSz="841157" rtl="0" eaLnBrk="1" latinLnBrk="0" hangingPunct="1">
         <a:lnSpc>
           <a:spcPct val="90000"/>
         </a:lnSpc>
@@ -2724,7 +2695,7 @@
           <a:spcPct val="0"/>
         </a:spcBef>
         <a:buNone/>
-        <a:defRPr sz="4400" kern="1200">
+        <a:defRPr sz="4048" kern="1200">
           <a:solidFill>
             <a:schemeClr val="tx1"/>
           </a:solidFill>
@@ -2735,16 +2706,16 @@
       </a:lvl1pPr>
     </p:titleStyle>
     <p:bodyStyle>
-      <a:lvl1pPr marL="228600" indent="-228600" algn="l" defTabSz="914400" rtl="0" eaLnBrk="1" latinLnBrk="0" hangingPunct="1">
+      <a:lvl1pPr marL="210289" indent="-210289" algn="l" defTabSz="841157" rtl="0" eaLnBrk="1" latinLnBrk="0" hangingPunct="1">
         <a:lnSpc>
           <a:spcPct val="90000"/>
         </a:lnSpc>
         <a:spcBef>
-          <a:spcPts val="1000"/>
+          <a:spcPts val="920"/>
         </a:spcBef>
         <a:buFont typeface="Arial" panose="020B0604020202020204" pitchFamily="34" charset="0"/>
         <a:buChar char="•"/>
-        <a:defRPr sz="2800" kern="1200">
+        <a:defRPr sz="2576" kern="1200">
           <a:solidFill>
             <a:schemeClr val="tx1"/>
           </a:solidFill>
@@ -2753,16 +2724,16 @@
           <a:cs typeface="+mn-cs"/>
         </a:defRPr>
       </a:lvl1pPr>
-      <a:lvl2pPr marL="685800" indent="-228600" algn="l" defTabSz="914400" rtl="0" eaLnBrk="1" latinLnBrk="0" hangingPunct="1">
+      <a:lvl2pPr marL="630867" indent="-210289" algn="l" defTabSz="841157" rtl="0" eaLnBrk="1" latinLnBrk="0" hangingPunct="1">
         <a:lnSpc>
           <a:spcPct val="90000"/>
         </a:lnSpc>
         <a:spcBef>
-          <a:spcPts val="500"/>
+          <a:spcPts val="460"/>
         </a:spcBef>
         <a:buFont typeface="Arial" panose="020B0604020202020204" pitchFamily="34" charset="0"/>
         <a:buChar char="•"/>
-        <a:defRPr sz="2400" kern="1200">
+        <a:defRPr sz="2208" kern="1200">
           <a:solidFill>
             <a:schemeClr val="tx1"/>
           </a:solidFill>
@@ -2771,16 +2742,16 @@
           <a:cs typeface="+mn-cs"/>
         </a:defRPr>
       </a:lvl2pPr>
-      <a:lvl3pPr marL="1143000" indent="-228600" algn="l" defTabSz="914400" rtl="0" eaLnBrk="1" latinLnBrk="0" hangingPunct="1">
+      <a:lvl3pPr marL="1051446" indent="-210289" algn="l" defTabSz="841157" rtl="0" eaLnBrk="1" latinLnBrk="0" hangingPunct="1">
         <a:lnSpc>
           <a:spcPct val="90000"/>
         </a:lnSpc>
         <a:spcBef>
-          <a:spcPts val="500"/>
+          <a:spcPts val="460"/>
         </a:spcBef>
         <a:buFont typeface="Arial" panose="020B0604020202020204" pitchFamily="34" charset="0"/>
         <a:buChar char="•"/>
-        <a:defRPr sz="2000" kern="1200">
+        <a:defRPr sz="1840" kern="1200">
           <a:solidFill>
             <a:schemeClr val="tx1"/>
           </a:solidFill>
@@ -2789,16 +2760,16 @@
           <a:cs typeface="+mn-cs"/>
         </a:defRPr>
       </a:lvl3pPr>
-      <a:lvl4pPr marL="1600200" indent="-228600" algn="l" defTabSz="914400" rtl="0" eaLnBrk="1" latinLnBrk="0" hangingPunct="1">
+      <a:lvl4pPr marL="1472024" indent="-210289" algn="l" defTabSz="841157" rtl="0" eaLnBrk="1" latinLnBrk="0" hangingPunct="1">
         <a:lnSpc>
           <a:spcPct val="90000"/>
         </a:lnSpc>
         <a:spcBef>
-          <a:spcPts val="500"/>
+          <a:spcPts val="460"/>
         </a:spcBef>
         <a:buFont typeface="Arial" panose="020B0604020202020204" pitchFamily="34" charset="0"/>
         <a:buChar char="•"/>
-        <a:defRPr sz="1800" kern="1200">
+        <a:defRPr sz="1656" kern="1200">
           <a:solidFill>
             <a:schemeClr val="tx1"/>
           </a:solidFill>
@@ -2807,16 +2778,16 @@
           <a:cs typeface="+mn-cs"/>
         </a:defRPr>
       </a:lvl4pPr>
-      <a:lvl5pPr marL="2057400" indent="-228600" algn="l" defTabSz="914400" rtl="0" eaLnBrk="1" latinLnBrk="0" hangingPunct="1">
+      <a:lvl5pPr marL="1892602" indent="-210289" algn="l" defTabSz="841157" rtl="0" eaLnBrk="1" latinLnBrk="0" hangingPunct="1">
         <a:lnSpc>
           <a:spcPct val="90000"/>
         </a:lnSpc>
         <a:spcBef>
-          <a:spcPts val="500"/>
+          <a:spcPts val="460"/>
         </a:spcBef>
         <a:buFont typeface="Arial" panose="020B0604020202020204" pitchFamily="34" charset="0"/>
         <a:buChar char="•"/>
-        <a:defRPr sz="1800" kern="1200">
+        <a:defRPr sz="1656" kern="1200">
           <a:solidFill>
             <a:schemeClr val="tx1"/>
           </a:solidFill>
@@ -2825,16 +2796,16 @@
           <a:cs typeface="+mn-cs"/>
         </a:defRPr>
       </a:lvl5pPr>
-      <a:lvl6pPr marL="2514600" indent="-228600" algn="l" defTabSz="914400" rtl="0" eaLnBrk="1" latinLnBrk="0" hangingPunct="1">
+      <a:lvl6pPr marL="2313181" indent="-210289" algn="l" defTabSz="841157" rtl="0" eaLnBrk="1" latinLnBrk="0" hangingPunct="1">
         <a:lnSpc>
           <a:spcPct val="90000"/>
         </a:lnSpc>
         <a:spcBef>
-          <a:spcPts val="500"/>
+          <a:spcPts val="460"/>
         </a:spcBef>
         <a:buFont typeface="Arial" panose="020B0604020202020204" pitchFamily="34" charset="0"/>
         <a:buChar char="•"/>
-        <a:defRPr sz="1800" kern="1200">
+        <a:defRPr sz="1656" kern="1200">
           <a:solidFill>
             <a:schemeClr val="tx1"/>
           </a:solidFill>
@@ -2843,16 +2814,16 @@
           <a:cs typeface="+mn-cs"/>
         </a:defRPr>
       </a:lvl6pPr>
-      <a:lvl7pPr marL="2971800" indent="-228600" algn="l" defTabSz="914400" rtl="0" eaLnBrk="1" latinLnBrk="0" hangingPunct="1">
+      <a:lvl7pPr marL="2733759" indent="-210289" algn="l" defTabSz="841157" rtl="0" eaLnBrk="1" latinLnBrk="0" hangingPunct="1">
         <a:lnSpc>
           <a:spcPct val="90000"/>
         </a:lnSpc>
         <a:spcBef>
-          <a:spcPts val="500"/>
+          <a:spcPts val="460"/>
         </a:spcBef>
         <a:buFont typeface="Arial" panose="020B0604020202020204" pitchFamily="34" charset="0"/>
         <a:buChar char="•"/>
-        <a:defRPr sz="1800" kern="1200">
+        <a:defRPr sz="1656" kern="1200">
           <a:solidFill>
             <a:schemeClr val="tx1"/>
           </a:solidFill>
@@ -2861,16 +2832,16 @@
           <a:cs typeface="+mn-cs"/>
         </a:defRPr>
       </a:lvl7pPr>
-      <a:lvl8pPr marL="3429000" indent="-228600" algn="l" defTabSz="914400" rtl="0" eaLnBrk="1" latinLnBrk="0" hangingPunct="1">
+      <a:lvl8pPr marL="3154337" indent="-210289" algn="l" defTabSz="841157" rtl="0" eaLnBrk="1" latinLnBrk="0" hangingPunct="1">
         <a:lnSpc>
           <a:spcPct val="90000"/>
         </a:lnSpc>
         <a:spcBef>
-          <a:spcPts val="500"/>
+          <a:spcPts val="460"/>
         </a:spcBef>
         <a:buFont typeface="Arial" panose="020B0604020202020204" pitchFamily="34" charset="0"/>
         <a:buChar char="•"/>
-        <a:defRPr sz="1800" kern="1200">
+        <a:defRPr sz="1656" kern="1200">
           <a:solidFill>
             <a:schemeClr val="tx1"/>
           </a:solidFill>
@@ -2879,16 +2850,16 @@
           <a:cs typeface="+mn-cs"/>
         </a:defRPr>
       </a:lvl8pPr>
-      <a:lvl9pPr marL="3886200" indent="-228600" algn="l" defTabSz="914400" rtl="0" eaLnBrk="1" latinLnBrk="0" hangingPunct="1">
+      <a:lvl9pPr marL="3574915" indent="-210289" algn="l" defTabSz="841157" rtl="0" eaLnBrk="1" latinLnBrk="0" hangingPunct="1">
         <a:lnSpc>
           <a:spcPct val="90000"/>
         </a:lnSpc>
         <a:spcBef>
-          <a:spcPts val="500"/>
+          <a:spcPts val="460"/>
         </a:spcBef>
         <a:buFont typeface="Arial" panose="020B0604020202020204" pitchFamily="34" charset="0"/>
         <a:buChar char="•"/>
-        <a:defRPr sz="1800" kern="1200">
+        <a:defRPr sz="1656" kern="1200">
           <a:solidFill>
             <a:schemeClr val="tx1"/>
           </a:solidFill>
@@ -2902,8 +2873,8 @@
       <a:defPPr>
         <a:defRPr lang="en-US"/>
       </a:defPPr>
-      <a:lvl1pPr marL="0" algn="l" defTabSz="914400" rtl="0" eaLnBrk="1" latinLnBrk="0" hangingPunct="1">
-        <a:defRPr sz="1800" kern="1200">
+      <a:lvl1pPr marL="0" algn="l" defTabSz="841157" rtl="0" eaLnBrk="1" latinLnBrk="0" hangingPunct="1">
+        <a:defRPr sz="1656" kern="1200">
           <a:solidFill>
             <a:schemeClr val="tx1"/>
           </a:solidFill>
@@ -2912,8 +2883,8 @@
           <a:cs typeface="+mn-cs"/>
         </a:defRPr>
       </a:lvl1pPr>
-      <a:lvl2pPr marL="457200" algn="l" defTabSz="914400" rtl="0" eaLnBrk="1" latinLnBrk="0" hangingPunct="1">
-        <a:defRPr sz="1800" kern="1200">
+      <a:lvl2pPr marL="420578" algn="l" defTabSz="841157" rtl="0" eaLnBrk="1" latinLnBrk="0" hangingPunct="1">
+        <a:defRPr sz="1656" kern="1200">
           <a:solidFill>
             <a:schemeClr val="tx1"/>
           </a:solidFill>
@@ -2922,8 +2893,8 @@
           <a:cs typeface="+mn-cs"/>
         </a:defRPr>
       </a:lvl2pPr>
-      <a:lvl3pPr marL="914400" algn="l" defTabSz="914400" rtl="0" eaLnBrk="1" latinLnBrk="0" hangingPunct="1">
-        <a:defRPr sz="1800" kern="1200">
+      <a:lvl3pPr marL="841157" algn="l" defTabSz="841157" rtl="0" eaLnBrk="1" latinLnBrk="0" hangingPunct="1">
+        <a:defRPr sz="1656" kern="1200">
           <a:solidFill>
             <a:schemeClr val="tx1"/>
           </a:solidFill>
@@ -2932,8 +2903,8 @@
           <a:cs typeface="+mn-cs"/>
         </a:defRPr>
       </a:lvl3pPr>
-      <a:lvl4pPr marL="1371600" algn="l" defTabSz="914400" rtl="0" eaLnBrk="1" latinLnBrk="0" hangingPunct="1">
-        <a:defRPr sz="1800" kern="1200">
+      <a:lvl4pPr marL="1261735" algn="l" defTabSz="841157" rtl="0" eaLnBrk="1" latinLnBrk="0" hangingPunct="1">
+        <a:defRPr sz="1656" kern="1200">
           <a:solidFill>
             <a:schemeClr val="tx1"/>
           </a:solidFill>
@@ -2942,8 +2913,8 @@
           <a:cs typeface="+mn-cs"/>
         </a:defRPr>
       </a:lvl4pPr>
-      <a:lvl5pPr marL="1828800" algn="l" defTabSz="914400" rtl="0" eaLnBrk="1" latinLnBrk="0" hangingPunct="1">
-        <a:defRPr sz="1800" kern="1200">
+      <a:lvl5pPr marL="1682313" algn="l" defTabSz="841157" rtl="0" eaLnBrk="1" latinLnBrk="0" hangingPunct="1">
+        <a:defRPr sz="1656" kern="1200">
           <a:solidFill>
             <a:schemeClr val="tx1"/>
           </a:solidFill>
@@ -2952,8 +2923,8 @@
           <a:cs typeface="+mn-cs"/>
         </a:defRPr>
       </a:lvl5pPr>
-      <a:lvl6pPr marL="2286000" algn="l" defTabSz="914400" rtl="0" eaLnBrk="1" latinLnBrk="0" hangingPunct="1">
-        <a:defRPr sz="1800" kern="1200">
+      <a:lvl6pPr marL="2102891" algn="l" defTabSz="841157" rtl="0" eaLnBrk="1" latinLnBrk="0" hangingPunct="1">
+        <a:defRPr sz="1656" kern="1200">
           <a:solidFill>
             <a:schemeClr val="tx1"/>
           </a:solidFill>
@@ -2962,8 +2933,8 @@
           <a:cs typeface="+mn-cs"/>
         </a:defRPr>
       </a:lvl6pPr>
-      <a:lvl7pPr marL="2743200" algn="l" defTabSz="914400" rtl="0" eaLnBrk="1" latinLnBrk="0" hangingPunct="1">
-        <a:defRPr sz="1800" kern="1200">
+      <a:lvl7pPr marL="2523470" algn="l" defTabSz="841157" rtl="0" eaLnBrk="1" latinLnBrk="0" hangingPunct="1">
+        <a:defRPr sz="1656" kern="1200">
           <a:solidFill>
             <a:schemeClr val="tx1"/>
           </a:solidFill>
@@ -2972,8 +2943,8 @@
           <a:cs typeface="+mn-cs"/>
         </a:defRPr>
       </a:lvl7pPr>
-      <a:lvl8pPr marL="3200400" algn="l" defTabSz="914400" rtl="0" eaLnBrk="1" latinLnBrk="0" hangingPunct="1">
-        <a:defRPr sz="1800" kern="1200">
+      <a:lvl8pPr marL="2944048" algn="l" defTabSz="841157" rtl="0" eaLnBrk="1" latinLnBrk="0" hangingPunct="1">
+        <a:defRPr sz="1656" kern="1200">
           <a:solidFill>
             <a:schemeClr val="tx1"/>
           </a:solidFill>
@@ -2982,8 +2953,8 @@
           <a:cs typeface="+mn-cs"/>
         </a:defRPr>
       </a:lvl8pPr>
-      <a:lvl9pPr marL="3657600" algn="l" defTabSz="914400" rtl="0" eaLnBrk="1" latinLnBrk="0" hangingPunct="1">
-        <a:defRPr sz="1800" kern="1200">
+      <a:lvl9pPr marL="3364626" algn="l" defTabSz="841157" rtl="0" eaLnBrk="1" latinLnBrk="0" hangingPunct="1">
+        <a:defRPr sz="1656" kern="1200">
           <a:solidFill>
             <a:schemeClr val="tx1"/>
           </a:solidFill>
@@ -3000,140 +2971,20 @@
 <file path=ppt/slides/slide1.xml><?xml version="1.0" encoding="utf-8"?>
 <p:sld xmlns:a="http://schemas.openxmlformats.org/drawingml/2006/main" xmlns:r="http://schemas.openxmlformats.org/officeDocument/2006/relationships" xmlns:p="http://schemas.openxmlformats.org/presentationml/2006/main">
   <p:cSld>
-    <p:spTree>
-      <p:nvGrpSpPr>
-        <p:cNvPr id="1" name=""/>
-        <p:cNvGrpSpPr/>
-        <p:nvPr/>
-      </p:nvGrpSpPr>
-      <p:grpSpPr>
-        <a:xfrm>
-          <a:off x="0" y="0"/>
-          <a:ext cx="0" cy="0"/>
-          <a:chOff x="0" y="0"/>
-          <a:chExt cx="0" cy="0"/>
-        </a:xfrm>
-      </p:grpSpPr>
-      <p:sp>
-        <p:nvSpPr>
-          <p:cNvPr id="2" name="Title 1">
-            <a:extLst>
-              <a:ext uri="{FF2B5EF4-FFF2-40B4-BE49-F238E27FC236}">
-                <a16:creationId xmlns:a16="http://schemas.microsoft.com/office/drawing/2014/main" id="{D23856C5-4E0E-B59F-F3E6-7A3534CCCAF4}"/>
-              </a:ext>
-            </a:extLst>
-          </p:cNvPr>
-          <p:cNvSpPr>
-            <a:spLocks noGrp="1"/>
-          </p:cNvSpPr>
-          <p:nvPr>
-            <p:ph type="ctrTitle"/>
-          </p:nvPr>
-        </p:nvSpPr>
-        <p:spPr/>
-        <p:txBody>
-          <a:bodyPr/>
-          <a:lstStyle/>
-          <a:p>
-            <a:endParaRPr lang="en-US" dirty="0"/>
-          </a:p>
-        </p:txBody>
-      </p:sp>
-      <p:sp>
-        <p:nvSpPr>
-          <p:cNvPr id="3" name="Subtitle 2">
-            <a:extLst>
-              <a:ext uri="{FF2B5EF4-FFF2-40B4-BE49-F238E27FC236}">
-                <a16:creationId xmlns:a16="http://schemas.microsoft.com/office/drawing/2014/main" id="{7D4CD77B-FD5A-6721-3E71-F8D15BBA8521}"/>
-              </a:ext>
-            </a:extLst>
-          </p:cNvPr>
-          <p:cNvSpPr>
-            <a:spLocks noGrp="1"/>
-          </p:cNvSpPr>
-          <p:nvPr>
-            <p:ph type="subTitle" idx="1"/>
-          </p:nvPr>
-        </p:nvSpPr>
-        <p:spPr/>
-        <p:txBody>
-          <a:bodyPr/>
-          <a:lstStyle/>
-          <a:p>
-            <a:endParaRPr lang="en-US"/>
-          </a:p>
-        </p:txBody>
-      </p:sp>
-      <p:pic>
-        <p:nvPicPr>
-          <p:cNvPr id="27" name="Picture 26">
-            <a:extLst>
-              <a:ext uri="{FF2B5EF4-FFF2-40B4-BE49-F238E27FC236}">
-                <a16:creationId xmlns:a16="http://schemas.microsoft.com/office/drawing/2014/main" id="{9B9F38F4-4BB6-3B26-A294-1D9486388E26}"/>
-              </a:ext>
-            </a:extLst>
-          </p:cNvPr>
-          <p:cNvPicPr>
-            <a:picLocks noChangeAspect="1"/>
-          </p:cNvPicPr>
-          <p:nvPr/>
-        </p:nvPicPr>
-        <p:blipFill>
-          <a:blip r:embed="rId2">
-            <a:extLst>
-              <a:ext uri="{28A0092B-C50C-407E-A947-70E740481C1C}">
-                <a14:useLocalDpi xmlns:a14="http://schemas.microsoft.com/office/drawing/2010/main" val="0"/>
-              </a:ext>
-            </a:extLst>
-          </a:blip>
-          <a:stretch>
-            <a:fillRect/>
-          </a:stretch>
-        </p:blipFill>
-        <p:spPr>
-          <a:xfrm>
-            <a:off x="0" y="198192"/>
-            <a:ext cx="9144000" cy="6461615"/>
-          </a:xfrm>
-          <a:prstGeom prst="rect">
-            <a:avLst/>
-          </a:prstGeom>
-        </p:spPr>
-      </p:pic>
-    </p:spTree>
-    <p:extLst>
-      <p:ext uri="{BB962C8B-B14F-4D97-AF65-F5344CB8AC3E}">
-        <p14:creationId xmlns:p14="http://schemas.microsoft.com/office/powerpoint/2010/main" val="1964188262"/>
-      </p:ext>
-    </p:extLst>
-  </p:cSld>
-  <p:clrMapOvr>
-    <a:masterClrMapping/>
-  </p:clrMapOvr>
-  <mc:AlternateContent xmlns:mc="http://schemas.openxmlformats.org/markup-compatibility/2006">
-    <mc:Choice xmlns:p14="http://schemas.microsoft.com/office/powerpoint/2010/main" Requires="p14">
-      <p:transition spd="slow" p14:dur="2000">
-        <p:fade/>
-      </p:transition>
-    </mc:Choice>
-    <mc:Fallback>
-      <p:transition spd="slow">
-        <p:fade/>
-      </p:transition>
-    </mc:Fallback>
-  </mc:AlternateContent>
-</p:sld>
-</file>
-
-<file path=ppt/slides/slide10.xml><?xml version="1.0" encoding="utf-8"?>
-<p:sld xmlns:a="http://schemas.openxmlformats.org/drawingml/2006/main" xmlns:r="http://schemas.openxmlformats.org/officeDocument/2006/relationships" xmlns:p="http://schemas.openxmlformats.org/presentationml/2006/main">
-  <p:cSld>
+    <p:bg>
+      <p:bgPr>
+        <a:solidFill>
+          <a:srgbClr val="F0F3F8"/>
+        </a:solidFill>
+        <a:effectLst/>
+      </p:bgPr>
+    </p:bg>
     <p:spTree>
       <p:nvGrpSpPr>
         <p:cNvPr id="1" name="">
           <a:extLst>
             <a:ext uri="{FF2B5EF4-FFF2-40B4-BE49-F238E27FC236}">
-              <a16:creationId xmlns:a16="http://schemas.microsoft.com/office/drawing/2014/main" id="{C394DA4A-F832-C9E6-9185-94D454DA3197}"/>
+              <a16:creationId xmlns:a16="http://schemas.microsoft.com/office/drawing/2014/main" id="{82B629D3-DBCB-B00D-FC2E-62C6F1D7D6C4}"/>
             </a:ext>
           </a:extLst>
         </p:cNvPr>
@@ -3153,7 +3004,7 @@
           <p:cNvPr id="2" name="Title 1">
             <a:extLst>
               <a:ext uri="{FF2B5EF4-FFF2-40B4-BE49-F238E27FC236}">
-                <a16:creationId xmlns:a16="http://schemas.microsoft.com/office/drawing/2014/main" id="{55985E3C-DA9A-09D9-520A-365C556422D7}"/>
+                <a16:creationId xmlns:a16="http://schemas.microsoft.com/office/drawing/2014/main" id="{637187B1-E239-57AB-AA7B-B19B617FB843}"/>
               </a:ext>
             </a:extLst>
           </p:cNvPr>
@@ -3169,7 +3020,7 @@
           <a:bodyPr/>
           <a:lstStyle/>
           <a:p>
-            <a:endParaRPr lang="en-US" dirty="0"/>
+            <a:endParaRPr lang="en-US"/>
           </a:p>
         </p:txBody>
       </p:sp>
@@ -3178,7 +3029,7 @@
           <p:cNvPr id="3" name="Subtitle 2">
             <a:extLst>
               <a:ext uri="{FF2B5EF4-FFF2-40B4-BE49-F238E27FC236}">
-                <a16:creationId xmlns:a16="http://schemas.microsoft.com/office/drawing/2014/main" id="{FFF7A209-8288-D8DF-E203-408BC473FAA9}"/>
+                <a16:creationId xmlns:a16="http://schemas.microsoft.com/office/drawing/2014/main" id="{5C78CB39-9DED-E097-D5DB-AD05C2FED3CF}"/>
               </a:ext>
             </a:extLst>
           </p:cNvPr>
@@ -3200,10 +3051,10 @@
       </p:sp>
       <p:pic>
         <p:nvPicPr>
-          <p:cNvPr id="6" name="Picture 5">
+          <p:cNvPr id="5" name="Picture 4">
             <a:extLst>
               <a:ext uri="{FF2B5EF4-FFF2-40B4-BE49-F238E27FC236}">
-                <a16:creationId xmlns:a16="http://schemas.microsoft.com/office/drawing/2014/main" id="{BCA25C3A-1FB0-6B5E-B6BC-6766834393E0}"/>
+                <a16:creationId xmlns:a16="http://schemas.microsoft.com/office/drawing/2014/main" id="{20AA0151-7DB7-6C22-5268-A051F3A79678}"/>
               </a:ext>
             </a:extLst>
           </p:cNvPr>
@@ -3226,39 +3077,90 @@
         </p:blipFill>
         <p:spPr>
           <a:xfrm>
-            <a:off x="0" y="198192"/>
-            <a:ext cx="9144000" cy="6461615"/>
+            <a:off x="16898" y="0"/>
+            <a:ext cx="8927641" cy="6308725"/>
           </a:xfrm>
           <a:prstGeom prst="rect">
             <a:avLst/>
           </a:prstGeom>
         </p:spPr>
       </p:pic>
+      <p:sp>
+        <p:nvSpPr>
+          <p:cNvPr id="4" name="Rectangle 3"/>
+          <p:cNvSpPr/>
+          <p:nvPr/>
+        </p:nvSpPr>
+        <p:spPr>
+          <a:xfrm>
+            <a:off x="1725283" y="4175185"/>
+            <a:ext cx="5512279" cy="439947"/>
+          </a:xfrm>
+          <a:prstGeom prst="rect">
+            <a:avLst/>
+          </a:prstGeom>
+          <a:solidFill>
+            <a:srgbClr val="EFF4F8"/>
+          </a:solidFill>
+          <a:ln>
+            <a:noFill/>
+          </a:ln>
+        </p:spPr>
+        <p:style>
+          <a:lnRef idx="2">
+            <a:schemeClr val="accent1">
+              <a:shade val="50000"/>
+            </a:schemeClr>
+          </a:lnRef>
+          <a:fillRef idx="1">
+            <a:schemeClr val="accent1"/>
+          </a:fillRef>
+          <a:effectRef idx="0">
+            <a:schemeClr val="accent1"/>
+          </a:effectRef>
+          <a:fontRef idx="minor">
+            <a:schemeClr val="lt1"/>
+          </a:fontRef>
+        </p:style>
+        <p:txBody>
+          <a:bodyPr rtlCol="0" anchor="ctr"/>
+          <a:lstStyle/>
+          <a:p>
+            <a:pPr algn="ctr"/>
+            <a:endParaRPr lang="en-US"/>
+          </a:p>
+        </p:txBody>
+      </p:sp>
     </p:spTree>
     <p:extLst>
       <p:ext uri="{BB962C8B-B14F-4D97-AF65-F5344CB8AC3E}">
-        <p14:creationId xmlns:p14="http://schemas.microsoft.com/office/powerpoint/2010/main" val="4293698887"/>
+        <p14:creationId xmlns:p14="http://schemas.microsoft.com/office/powerpoint/2010/main" val="3308676928"/>
       </p:ext>
     </p:extLst>
   </p:cSld>
   <p:clrMapOvr>
     <a:masterClrMapping/>
   </p:clrMapOvr>
-  <p:transition>
-    <p:push dir="u"/>
-  </p:transition>
 </p:sld>
 </file>
 
-<file path=ppt/slides/slide2.xml><?xml version="1.0" encoding="utf-8"?>
+<file path=ppt/slides/slide10.xml><?xml version="1.0" encoding="utf-8"?>
 <p:sld xmlns:a="http://schemas.openxmlformats.org/drawingml/2006/main" xmlns:r="http://schemas.openxmlformats.org/officeDocument/2006/relationships" xmlns:p="http://schemas.openxmlformats.org/presentationml/2006/main">
   <p:cSld>
+    <p:bg>
+      <p:bgPr>
+        <a:solidFill>
+          <a:srgbClr val="F0F3F8"/>
+        </a:solidFill>
+        <a:effectLst/>
+      </p:bgPr>
+    </p:bg>
     <p:spTree>
       <p:nvGrpSpPr>
         <p:cNvPr id="1" name="">
           <a:extLst>
             <a:ext uri="{FF2B5EF4-FFF2-40B4-BE49-F238E27FC236}">
-              <a16:creationId xmlns:a16="http://schemas.microsoft.com/office/drawing/2014/main" id="{9E5B7A6D-4A98-BB4C-7DC1-D91ED013462D}"/>
+              <a16:creationId xmlns:a16="http://schemas.microsoft.com/office/drawing/2014/main" id="{9BC92F08-8C83-C885-EE7F-C8F3AEC05AA2}"/>
             </a:ext>
           </a:extLst>
         </p:cNvPr>
@@ -3278,7 +3180,7 @@
           <p:cNvPr id="2" name="Title 1">
             <a:extLst>
               <a:ext uri="{FF2B5EF4-FFF2-40B4-BE49-F238E27FC236}">
-                <a16:creationId xmlns:a16="http://schemas.microsoft.com/office/drawing/2014/main" id="{F61BF9DF-0627-43B7-7A01-30CEAE32397F}"/>
+                <a16:creationId xmlns:a16="http://schemas.microsoft.com/office/drawing/2014/main" id="{3E2C4196-FEE2-EA9D-287E-24FE13DCAA2E}"/>
               </a:ext>
             </a:extLst>
           </p:cNvPr>
@@ -3294,7 +3196,7 @@
           <a:bodyPr/>
           <a:lstStyle/>
           <a:p>
-            <a:endParaRPr lang="en-US" dirty="0"/>
+            <a:endParaRPr lang="en-US"/>
           </a:p>
         </p:txBody>
       </p:sp>
@@ -3303,7 +3205,7 @@
           <p:cNvPr id="3" name="Subtitle 2">
             <a:extLst>
               <a:ext uri="{FF2B5EF4-FFF2-40B4-BE49-F238E27FC236}">
-                <a16:creationId xmlns:a16="http://schemas.microsoft.com/office/drawing/2014/main" id="{D6CE468D-A27A-8516-ABF1-8E5CBF20B7FA}"/>
+                <a16:creationId xmlns:a16="http://schemas.microsoft.com/office/drawing/2014/main" id="{51CA42B5-B4E8-14F5-DFE4-8EE7E60E8505}"/>
               </a:ext>
             </a:extLst>
           </p:cNvPr>
@@ -3325,10 +3227,10 @@
       </p:sp>
       <p:pic>
         <p:nvPicPr>
-          <p:cNvPr id="7" name="Picture 6">
+          <p:cNvPr id="5" name="Picture 4">
             <a:extLst>
               <a:ext uri="{FF2B5EF4-FFF2-40B4-BE49-F238E27FC236}">
-                <a16:creationId xmlns:a16="http://schemas.microsoft.com/office/drawing/2014/main" id="{C8D52A7F-333B-D86F-78FB-0596CEDAB3E1}"/>
+                <a16:creationId xmlns:a16="http://schemas.microsoft.com/office/drawing/2014/main" id="{FCCD8E59-24C9-469A-9FE2-2F177036C765}"/>
               </a:ext>
             </a:extLst>
           </p:cNvPr>
@@ -3351,8 +3253,8 @@
         </p:blipFill>
         <p:spPr>
           <a:xfrm>
-            <a:off x="0" y="198192"/>
-            <a:ext cx="9144000" cy="6461615"/>
+            <a:off x="16898" y="0"/>
+            <a:ext cx="8927641" cy="6308725"/>
           </a:xfrm>
           <a:prstGeom prst="rect">
             <a:avLst/>
@@ -3362,28 +3264,45 @@
     </p:spTree>
     <p:extLst>
       <p:ext uri="{BB962C8B-B14F-4D97-AF65-F5344CB8AC3E}">
-        <p14:creationId xmlns:p14="http://schemas.microsoft.com/office/powerpoint/2010/main" val="4131957043"/>
+        <p14:creationId xmlns:p14="http://schemas.microsoft.com/office/powerpoint/2010/main" val="3847682286"/>
       </p:ext>
     </p:extLst>
   </p:cSld>
   <p:clrMapOvr>
     <a:masterClrMapping/>
   </p:clrMapOvr>
-  <p:transition>
-    <p:push dir="u"/>
-  </p:transition>
+  <mc:AlternateContent xmlns:mc="http://schemas.openxmlformats.org/markup-compatibility/2006" xmlns:p14="http://schemas.microsoft.com/office/powerpoint/2010/main">
+    <mc:Choice Requires="p14">
+      <p:transition spd="med" p14:dur="700">
+        <p:fade/>
+      </p:transition>
+    </mc:Choice>
+    <mc:Fallback xmlns="">
+      <p:transition spd="med">
+        <p:fade/>
+      </p:transition>
+    </mc:Fallback>
+  </mc:AlternateContent>
 </p:sld>
 </file>
 
-<file path=ppt/slides/slide3.xml><?xml version="1.0" encoding="utf-8"?>
+<file path=ppt/slides/slide11.xml><?xml version="1.0" encoding="utf-8"?>
 <p:sld xmlns:a="http://schemas.openxmlformats.org/drawingml/2006/main" xmlns:r="http://schemas.openxmlformats.org/officeDocument/2006/relationships" xmlns:p="http://schemas.openxmlformats.org/presentationml/2006/main">
   <p:cSld>
+    <p:bg>
+      <p:bgPr>
+        <a:solidFill>
+          <a:srgbClr val="F0F3F8"/>
+        </a:solidFill>
+        <a:effectLst/>
+      </p:bgPr>
+    </p:bg>
     <p:spTree>
       <p:nvGrpSpPr>
         <p:cNvPr id="1" name="">
           <a:extLst>
             <a:ext uri="{FF2B5EF4-FFF2-40B4-BE49-F238E27FC236}">
-              <a16:creationId xmlns:a16="http://schemas.microsoft.com/office/drawing/2014/main" id="{CC0B79F0-A735-3E12-0A23-6C9CD2E25F0F}"/>
+              <a16:creationId xmlns:a16="http://schemas.microsoft.com/office/drawing/2014/main" id="{1786E8E3-3F42-92F6-3948-CBB6E434011C}"/>
             </a:ext>
           </a:extLst>
         </p:cNvPr>
@@ -3403,7 +3322,7 @@
           <p:cNvPr id="2" name="Title 1">
             <a:extLst>
               <a:ext uri="{FF2B5EF4-FFF2-40B4-BE49-F238E27FC236}">
-                <a16:creationId xmlns:a16="http://schemas.microsoft.com/office/drawing/2014/main" id="{55984C2A-B4D6-2BDC-CD5D-9CD70BFEED85}"/>
+                <a16:creationId xmlns:a16="http://schemas.microsoft.com/office/drawing/2014/main" id="{23C653D5-D1D8-BD9A-2227-1A31E7879707}"/>
               </a:ext>
             </a:extLst>
           </p:cNvPr>
@@ -3419,7 +3338,7 @@
           <a:bodyPr/>
           <a:lstStyle/>
           <a:p>
-            <a:endParaRPr lang="en-US" dirty="0"/>
+            <a:endParaRPr lang="en-US"/>
           </a:p>
         </p:txBody>
       </p:sp>
@@ -3428,7 +3347,7 @@
           <p:cNvPr id="3" name="Subtitle 2">
             <a:extLst>
               <a:ext uri="{FF2B5EF4-FFF2-40B4-BE49-F238E27FC236}">
-                <a16:creationId xmlns:a16="http://schemas.microsoft.com/office/drawing/2014/main" id="{BBC13B15-7EB9-C423-9BAE-F253C716075B}"/>
+                <a16:creationId xmlns:a16="http://schemas.microsoft.com/office/drawing/2014/main" id="{831160D1-FDCA-5C33-2817-4B95CF6E0FA4}"/>
               </a:ext>
             </a:extLst>
           </p:cNvPr>
@@ -3453,7 +3372,7 @@
           <p:cNvPr id="5" name="Picture 4">
             <a:extLst>
               <a:ext uri="{FF2B5EF4-FFF2-40B4-BE49-F238E27FC236}">
-                <a16:creationId xmlns:a16="http://schemas.microsoft.com/office/drawing/2014/main" id="{881F68FC-B958-7AA5-EE20-99DDF29FC4D1}"/>
+                <a16:creationId xmlns:a16="http://schemas.microsoft.com/office/drawing/2014/main" id="{4FBD2ED5-10E1-5266-9A70-63FF170893DB}"/>
               </a:ext>
             </a:extLst>
           </p:cNvPr>
@@ -3476,8 +3395,8 @@
         </p:blipFill>
         <p:spPr>
           <a:xfrm>
-            <a:off x="0" y="198192"/>
-            <a:ext cx="9144000" cy="6461615"/>
+            <a:off x="16898" y="0"/>
+            <a:ext cx="8927641" cy="6308725"/>
           </a:xfrm>
           <a:prstGeom prst="rect">
             <a:avLst/>
@@ -3487,28 +3406,45 @@
     </p:spTree>
     <p:extLst>
       <p:ext uri="{BB962C8B-B14F-4D97-AF65-F5344CB8AC3E}">
-        <p14:creationId xmlns:p14="http://schemas.microsoft.com/office/powerpoint/2010/main" val="2559522230"/>
+        <p14:creationId xmlns:p14="http://schemas.microsoft.com/office/powerpoint/2010/main" val="3932288524"/>
       </p:ext>
     </p:extLst>
   </p:cSld>
   <p:clrMapOvr>
     <a:masterClrMapping/>
   </p:clrMapOvr>
-  <p:transition>
-    <p:push dir="u"/>
-  </p:transition>
+  <mc:AlternateContent xmlns:mc="http://schemas.openxmlformats.org/markup-compatibility/2006" xmlns:p14="http://schemas.microsoft.com/office/powerpoint/2010/main">
+    <mc:Choice Requires="p14">
+      <p:transition spd="med" p14:dur="700">
+        <p:fade/>
+      </p:transition>
+    </mc:Choice>
+    <mc:Fallback xmlns="">
+      <p:transition spd="med">
+        <p:fade/>
+      </p:transition>
+    </mc:Fallback>
+  </mc:AlternateContent>
 </p:sld>
 </file>
 
-<file path=ppt/slides/slide4.xml><?xml version="1.0" encoding="utf-8"?>
+<file path=ppt/slides/slide12.xml><?xml version="1.0" encoding="utf-8"?>
 <p:sld xmlns:a="http://schemas.openxmlformats.org/drawingml/2006/main" xmlns:r="http://schemas.openxmlformats.org/officeDocument/2006/relationships" xmlns:p="http://schemas.openxmlformats.org/presentationml/2006/main">
   <p:cSld>
+    <p:bg>
+      <p:bgPr>
+        <a:solidFill>
+          <a:srgbClr val="F0F3F8"/>
+        </a:solidFill>
+        <a:effectLst/>
+      </p:bgPr>
+    </p:bg>
     <p:spTree>
       <p:nvGrpSpPr>
         <p:cNvPr id="1" name="">
           <a:extLst>
             <a:ext uri="{FF2B5EF4-FFF2-40B4-BE49-F238E27FC236}">
-              <a16:creationId xmlns:a16="http://schemas.microsoft.com/office/drawing/2014/main" id="{2620D362-1973-166D-1DB5-881BFB58A329}"/>
+              <a16:creationId xmlns:a16="http://schemas.microsoft.com/office/drawing/2014/main" id="{5810EB22-74B9-C917-8F38-7A81665B2D46}"/>
             </a:ext>
           </a:extLst>
         </p:cNvPr>
@@ -3528,7 +3464,7 @@
           <p:cNvPr id="2" name="Title 1">
             <a:extLst>
               <a:ext uri="{FF2B5EF4-FFF2-40B4-BE49-F238E27FC236}">
-                <a16:creationId xmlns:a16="http://schemas.microsoft.com/office/drawing/2014/main" id="{34BF2B97-1839-406B-51D2-983F18EBE62A}"/>
+                <a16:creationId xmlns:a16="http://schemas.microsoft.com/office/drawing/2014/main" id="{B8D90179-7359-0B65-16F6-25802673260B}"/>
               </a:ext>
             </a:extLst>
           </p:cNvPr>
@@ -3544,7 +3480,7 @@
           <a:bodyPr/>
           <a:lstStyle/>
           <a:p>
-            <a:endParaRPr lang="en-US" dirty="0"/>
+            <a:endParaRPr lang="en-US"/>
           </a:p>
         </p:txBody>
       </p:sp>
@@ -3553,7 +3489,7 @@
           <p:cNvPr id="3" name="Subtitle 2">
             <a:extLst>
               <a:ext uri="{FF2B5EF4-FFF2-40B4-BE49-F238E27FC236}">
-                <a16:creationId xmlns:a16="http://schemas.microsoft.com/office/drawing/2014/main" id="{C5078B30-A054-8941-4B13-82908D60F109}"/>
+                <a16:creationId xmlns:a16="http://schemas.microsoft.com/office/drawing/2014/main" id="{6888858E-3321-7755-40AC-87773B561966}"/>
               </a:ext>
             </a:extLst>
           </p:cNvPr>
@@ -3578,7 +3514,7 @@
           <p:cNvPr id="5" name="Picture 4">
             <a:extLst>
               <a:ext uri="{FF2B5EF4-FFF2-40B4-BE49-F238E27FC236}">
-                <a16:creationId xmlns:a16="http://schemas.microsoft.com/office/drawing/2014/main" id="{0BD144B0-272C-3DEC-8B59-301823C9EB15}"/>
+                <a16:creationId xmlns:a16="http://schemas.microsoft.com/office/drawing/2014/main" id="{40CB87E4-6841-A80E-B9B6-1910D7DE4D6D}"/>
               </a:ext>
             </a:extLst>
           </p:cNvPr>
@@ -3601,8 +3537,8 @@
         </p:blipFill>
         <p:spPr>
           <a:xfrm>
-            <a:off x="0" y="198192"/>
-            <a:ext cx="9144000" cy="6461615"/>
+            <a:off x="16898" y="0"/>
+            <a:ext cx="8927641" cy="6308725"/>
           </a:xfrm>
           <a:prstGeom prst="rect">
             <a:avLst/>
@@ -3612,28 +3548,45 @@
     </p:spTree>
     <p:extLst>
       <p:ext uri="{BB962C8B-B14F-4D97-AF65-F5344CB8AC3E}">
-        <p14:creationId xmlns:p14="http://schemas.microsoft.com/office/powerpoint/2010/main" val="1800033687"/>
+        <p14:creationId xmlns:p14="http://schemas.microsoft.com/office/powerpoint/2010/main" val="1879172663"/>
       </p:ext>
     </p:extLst>
   </p:cSld>
   <p:clrMapOvr>
     <a:masterClrMapping/>
   </p:clrMapOvr>
-  <p:transition>
-    <p:push dir="u"/>
-  </p:transition>
+  <mc:AlternateContent xmlns:mc="http://schemas.openxmlformats.org/markup-compatibility/2006" xmlns:p14="http://schemas.microsoft.com/office/powerpoint/2010/main">
+    <mc:Choice Requires="p14">
+      <p:transition spd="med" p14:dur="700">
+        <p:fade/>
+      </p:transition>
+    </mc:Choice>
+    <mc:Fallback xmlns="">
+      <p:transition spd="med">
+        <p:fade/>
+      </p:transition>
+    </mc:Fallback>
+  </mc:AlternateContent>
 </p:sld>
 </file>
 
-<file path=ppt/slides/slide5.xml><?xml version="1.0" encoding="utf-8"?>
+<file path=ppt/slides/slide13.xml><?xml version="1.0" encoding="utf-8"?>
 <p:sld xmlns:a="http://schemas.openxmlformats.org/drawingml/2006/main" xmlns:r="http://schemas.openxmlformats.org/officeDocument/2006/relationships" xmlns:p="http://schemas.openxmlformats.org/presentationml/2006/main">
   <p:cSld>
+    <p:bg>
+      <p:bgPr>
+        <a:solidFill>
+          <a:srgbClr val="F0F3F8"/>
+        </a:solidFill>
+        <a:effectLst/>
+      </p:bgPr>
+    </p:bg>
     <p:spTree>
       <p:nvGrpSpPr>
         <p:cNvPr id="1" name="">
           <a:extLst>
             <a:ext uri="{FF2B5EF4-FFF2-40B4-BE49-F238E27FC236}">
-              <a16:creationId xmlns:a16="http://schemas.microsoft.com/office/drawing/2014/main" id="{FACE9C2F-9573-395E-B040-B4E4D80E0A3F}"/>
+              <a16:creationId xmlns:a16="http://schemas.microsoft.com/office/drawing/2014/main" id="{1EBBF7DB-6D9E-C3AD-A73C-B8752586D935}"/>
             </a:ext>
           </a:extLst>
         </p:cNvPr>
@@ -3653,7 +3606,7 @@
           <p:cNvPr id="2" name="Title 1">
             <a:extLst>
               <a:ext uri="{FF2B5EF4-FFF2-40B4-BE49-F238E27FC236}">
-                <a16:creationId xmlns:a16="http://schemas.microsoft.com/office/drawing/2014/main" id="{5E817586-416A-EE9B-C16B-8291E07E4796}"/>
+                <a16:creationId xmlns:a16="http://schemas.microsoft.com/office/drawing/2014/main" id="{31FAABD0-1C03-7F4E-3C0A-01507FC800AF}"/>
               </a:ext>
             </a:extLst>
           </p:cNvPr>
@@ -3669,7 +3622,7 @@
           <a:bodyPr/>
           <a:lstStyle/>
           <a:p>
-            <a:endParaRPr lang="en-US" dirty="0"/>
+            <a:endParaRPr lang="en-US"/>
           </a:p>
         </p:txBody>
       </p:sp>
@@ -3678,7 +3631,7 @@
           <p:cNvPr id="3" name="Subtitle 2">
             <a:extLst>
               <a:ext uri="{FF2B5EF4-FFF2-40B4-BE49-F238E27FC236}">
-                <a16:creationId xmlns:a16="http://schemas.microsoft.com/office/drawing/2014/main" id="{6457455B-3F5B-FDD3-8E28-4BAE849CAC4C}"/>
+                <a16:creationId xmlns:a16="http://schemas.microsoft.com/office/drawing/2014/main" id="{AE97CFF0-8587-6CE8-8B51-8B28BB21C24B}"/>
               </a:ext>
             </a:extLst>
           </p:cNvPr>
@@ -3703,7 +3656,7 @@
           <p:cNvPr id="5" name="Picture 4">
             <a:extLst>
               <a:ext uri="{FF2B5EF4-FFF2-40B4-BE49-F238E27FC236}">
-                <a16:creationId xmlns:a16="http://schemas.microsoft.com/office/drawing/2014/main" id="{0EFC3BAB-E7D4-F57A-90E3-3F4B1864217A}"/>
+                <a16:creationId xmlns:a16="http://schemas.microsoft.com/office/drawing/2014/main" id="{42797129-8226-5911-3545-D8B11D245EAD}"/>
               </a:ext>
             </a:extLst>
           </p:cNvPr>
@@ -3726,8 +3679,8 @@
         </p:blipFill>
         <p:spPr>
           <a:xfrm>
-            <a:off x="0" y="198192"/>
-            <a:ext cx="9144000" cy="6461615"/>
+            <a:off x="16898" y="0"/>
+            <a:ext cx="8927641" cy="6308725"/>
           </a:xfrm>
           <a:prstGeom prst="rect">
             <a:avLst/>
@@ -3737,28 +3690,45 @@
     </p:spTree>
     <p:extLst>
       <p:ext uri="{BB962C8B-B14F-4D97-AF65-F5344CB8AC3E}">
-        <p14:creationId xmlns:p14="http://schemas.microsoft.com/office/powerpoint/2010/main" val="4237568285"/>
+        <p14:creationId xmlns:p14="http://schemas.microsoft.com/office/powerpoint/2010/main" val="3175949662"/>
       </p:ext>
     </p:extLst>
   </p:cSld>
   <p:clrMapOvr>
     <a:masterClrMapping/>
   </p:clrMapOvr>
-  <p:transition>
-    <p:push dir="u"/>
-  </p:transition>
+  <mc:AlternateContent xmlns:mc="http://schemas.openxmlformats.org/markup-compatibility/2006" xmlns:p14="http://schemas.microsoft.com/office/powerpoint/2010/main">
+    <mc:Choice Requires="p14">
+      <p:transition spd="med" p14:dur="700">
+        <p:fade/>
+      </p:transition>
+    </mc:Choice>
+    <mc:Fallback xmlns="">
+      <p:transition spd="med">
+        <p:fade/>
+      </p:transition>
+    </mc:Fallback>
+  </mc:AlternateContent>
 </p:sld>
 </file>
 
-<file path=ppt/slides/slide6.xml><?xml version="1.0" encoding="utf-8"?>
+<file path=ppt/slides/slide14.xml><?xml version="1.0" encoding="utf-8"?>
 <p:sld xmlns:a="http://schemas.openxmlformats.org/drawingml/2006/main" xmlns:r="http://schemas.openxmlformats.org/officeDocument/2006/relationships" xmlns:p="http://schemas.openxmlformats.org/presentationml/2006/main">
   <p:cSld>
+    <p:bg>
+      <p:bgPr>
+        <a:solidFill>
+          <a:srgbClr val="F0F3F8"/>
+        </a:solidFill>
+        <a:effectLst/>
+      </p:bgPr>
+    </p:bg>
     <p:spTree>
       <p:nvGrpSpPr>
         <p:cNvPr id="1" name="">
           <a:extLst>
             <a:ext uri="{FF2B5EF4-FFF2-40B4-BE49-F238E27FC236}">
-              <a16:creationId xmlns:a16="http://schemas.microsoft.com/office/drawing/2014/main" id="{965C0E6F-2957-B1E4-425F-913633D2B913}"/>
+              <a16:creationId xmlns:a16="http://schemas.microsoft.com/office/drawing/2014/main" id="{31EE8579-EDE1-2F92-9A6E-1C04C4CD23BF}"/>
             </a:ext>
           </a:extLst>
         </p:cNvPr>
@@ -3778,7 +3748,7 @@
           <p:cNvPr id="2" name="Title 1">
             <a:extLst>
               <a:ext uri="{FF2B5EF4-FFF2-40B4-BE49-F238E27FC236}">
-                <a16:creationId xmlns:a16="http://schemas.microsoft.com/office/drawing/2014/main" id="{FDACD470-2E5E-0EB7-B04A-9011DC08A395}"/>
+                <a16:creationId xmlns:a16="http://schemas.microsoft.com/office/drawing/2014/main" id="{C5A2848B-353E-A263-AFF6-6F83B80E823E}"/>
               </a:ext>
             </a:extLst>
           </p:cNvPr>
@@ -3794,7 +3764,7 @@
           <a:bodyPr/>
           <a:lstStyle/>
           <a:p>
-            <a:endParaRPr lang="en-US" dirty="0"/>
+            <a:endParaRPr lang="en-US"/>
           </a:p>
         </p:txBody>
       </p:sp>
@@ -3803,7 +3773,7 @@
           <p:cNvPr id="3" name="Subtitle 2">
             <a:extLst>
               <a:ext uri="{FF2B5EF4-FFF2-40B4-BE49-F238E27FC236}">
-                <a16:creationId xmlns:a16="http://schemas.microsoft.com/office/drawing/2014/main" id="{E8635714-BBA4-9681-F312-1483335589D4}"/>
+                <a16:creationId xmlns:a16="http://schemas.microsoft.com/office/drawing/2014/main" id="{0B723AEE-342B-C7D8-A0A1-AE0FD9828696}"/>
               </a:ext>
             </a:extLst>
           </p:cNvPr>
@@ -3825,13 +3795,7 @@
       </p:sp>
       <p:pic>
         <p:nvPicPr>
-          <p:cNvPr id="6" name="Picture 5">
-            <a:extLst>
-              <a:ext uri="{FF2B5EF4-FFF2-40B4-BE49-F238E27FC236}">
-                <a16:creationId xmlns:a16="http://schemas.microsoft.com/office/drawing/2014/main" id="{78141541-C8F7-026E-858B-82BDF31A054C}"/>
-              </a:ext>
-            </a:extLst>
-          </p:cNvPr>
+          <p:cNvPr id="4" name="Picture 3"/>
           <p:cNvPicPr>
             <a:picLocks noChangeAspect="1"/>
           </p:cNvPicPr>
@@ -3851,8 +3815,8 @@
         </p:blipFill>
         <p:spPr>
           <a:xfrm>
-            <a:off x="0" y="198192"/>
-            <a:ext cx="9144000" cy="6461615"/>
+            <a:off x="37792" y="0"/>
+            <a:ext cx="8923646" cy="6308725"/>
           </a:xfrm>
           <a:prstGeom prst="rect">
             <a:avLst/>
@@ -3862,28 +3826,45 @@
     </p:spTree>
     <p:extLst>
       <p:ext uri="{BB962C8B-B14F-4D97-AF65-F5344CB8AC3E}">
-        <p14:creationId xmlns:p14="http://schemas.microsoft.com/office/powerpoint/2010/main" val="3418714614"/>
+        <p14:creationId xmlns:p14="http://schemas.microsoft.com/office/powerpoint/2010/main" val="1508171143"/>
       </p:ext>
     </p:extLst>
   </p:cSld>
   <p:clrMapOvr>
     <a:masterClrMapping/>
   </p:clrMapOvr>
-  <p:transition>
-    <p:push dir="u"/>
-  </p:transition>
+  <mc:AlternateContent xmlns:mc="http://schemas.openxmlformats.org/markup-compatibility/2006" xmlns:p14="http://schemas.microsoft.com/office/powerpoint/2010/main">
+    <mc:Choice Requires="p14">
+      <p:transition spd="med" p14:dur="700">
+        <p:fade/>
+      </p:transition>
+    </mc:Choice>
+    <mc:Fallback xmlns="">
+      <p:transition spd="med">
+        <p:fade/>
+      </p:transition>
+    </mc:Fallback>
+  </mc:AlternateContent>
 </p:sld>
 </file>
 
-<file path=ppt/slides/slide7.xml><?xml version="1.0" encoding="utf-8"?>
+<file path=ppt/slides/slide15.xml><?xml version="1.0" encoding="utf-8"?>
 <p:sld xmlns:a="http://schemas.openxmlformats.org/drawingml/2006/main" xmlns:r="http://schemas.openxmlformats.org/officeDocument/2006/relationships" xmlns:p="http://schemas.openxmlformats.org/presentationml/2006/main">
   <p:cSld>
+    <p:bg>
+      <p:bgPr>
+        <a:solidFill>
+          <a:srgbClr val="F0F3F8"/>
+        </a:solidFill>
+        <a:effectLst/>
+      </p:bgPr>
+    </p:bg>
     <p:spTree>
       <p:nvGrpSpPr>
         <p:cNvPr id="1" name="">
           <a:extLst>
             <a:ext uri="{FF2B5EF4-FFF2-40B4-BE49-F238E27FC236}">
-              <a16:creationId xmlns:a16="http://schemas.microsoft.com/office/drawing/2014/main" id="{E0239B25-CA72-3872-4736-024376EA7478}"/>
+              <a16:creationId xmlns:a16="http://schemas.microsoft.com/office/drawing/2014/main" id="{3883844C-F36C-ABB7-0D40-1DEDEB8F6C9F}"/>
             </a:ext>
           </a:extLst>
         </p:cNvPr>
@@ -3903,7 +3884,7 @@
           <p:cNvPr id="2" name="Title 1">
             <a:extLst>
               <a:ext uri="{FF2B5EF4-FFF2-40B4-BE49-F238E27FC236}">
-                <a16:creationId xmlns:a16="http://schemas.microsoft.com/office/drawing/2014/main" id="{5895E51C-DD5A-CD1E-72E8-FFAFE91AAC5A}"/>
+                <a16:creationId xmlns:a16="http://schemas.microsoft.com/office/drawing/2014/main" id="{1BCC3C68-076A-5501-38C1-B47C5DA62503}"/>
               </a:ext>
             </a:extLst>
           </p:cNvPr>
@@ -3919,7 +3900,7 @@
           <a:bodyPr/>
           <a:lstStyle/>
           <a:p>
-            <a:endParaRPr lang="en-US" dirty="0"/>
+            <a:endParaRPr lang="en-US"/>
           </a:p>
         </p:txBody>
       </p:sp>
@@ -3928,7 +3909,7 @@
           <p:cNvPr id="3" name="Subtitle 2">
             <a:extLst>
               <a:ext uri="{FF2B5EF4-FFF2-40B4-BE49-F238E27FC236}">
-                <a16:creationId xmlns:a16="http://schemas.microsoft.com/office/drawing/2014/main" id="{ED8030C8-F367-7804-3E93-1A9809454E24}"/>
+                <a16:creationId xmlns:a16="http://schemas.microsoft.com/office/drawing/2014/main" id="{3A3C7E9F-DE38-17C9-456E-6E4026155CCE}"/>
               </a:ext>
             </a:extLst>
           </p:cNvPr>
@@ -3950,10 +3931,10 @@
       </p:sp>
       <p:pic>
         <p:nvPicPr>
-          <p:cNvPr id="5" name="Picture 4">
+          <p:cNvPr id="9" name="Picture 8">
             <a:extLst>
               <a:ext uri="{FF2B5EF4-FFF2-40B4-BE49-F238E27FC236}">
-                <a16:creationId xmlns:a16="http://schemas.microsoft.com/office/drawing/2014/main" id="{F79625CB-2D2A-F706-33EF-C6D4979A43D0}"/>
+                <a16:creationId xmlns:a16="http://schemas.microsoft.com/office/drawing/2014/main" id="{C5D09966-712C-FFE3-D935-9C20F7989CC1}"/>
               </a:ext>
             </a:extLst>
           </p:cNvPr>
@@ -3976,8 +3957,8 @@
         </p:blipFill>
         <p:spPr>
           <a:xfrm>
-            <a:off x="0" y="198192"/>
-            <a:ext cx="9144000" cy="6461615"/>
+            <a:off x="16898" y="0"/>
+            <a:ext cx="8927641" cy="6308725"/>
           </a:xfrm>
           <a:prstGeom prst="rect">
             <a:avLst/>
@@ -3987,28 +3968,45 @@
     </p:spTree>
     <p:extLst>
       <p:ext uri="{BB962C8B-B14F-4D97-AF65-F5344CB8AC3E}">
-        <p14:creationId xmlns:p14="http://schemas.microsoft.com/office/powerpoint/2010/main" val="1063317634"/>
+        <p14:creationId xmlns:p14="http://schemas.microsoft.com/office/powerpoint/2010/main" val="2658712272"/>
       </p:ext>
     </p:extLst>
   </p:cSld>
   <p:clrMapOvr>
     <a:masterClrMapping/>
   </p:clrMapOvr>
-  <p:transition>
-    <p:push dir="u"/>
-  </p:transition>
+  <mc:AlternateContent xmlns:mc="http://schemas.openxmlformats.org/markup-compatibility/2006" xmlns:p14="http://schemas.microsoft.com/office/powerpoint/2010/main">
+    <mc:Choice Requires="p14">
+      <p:transition spd="med" p14:dur="700">
+        <p:fade/>
+      </p:transition>
+    </mc:Choice>
+    <mc:Fallback xmlns="">
+      <p:transition spd="med">
+        <p:fade/>
+      </p:transition>
+    </mc:Fallback>
+  </mc:AlternateContent>
 </p:sld>
 </file>
 
-<file path=ppt/slides/slide8.xml><?xml version="1.0" encoding="utf-8"?>
+<file path=ppt/slides/slide2.xml><?xml version="1.0" encoding="utf-8"?>
 <p:sld xmlns:a="http://schemas.openxmlformats.org/drawingml/2006/main" xmlns:r="http://schemas.openxmlformats.org/officeDocument/2006/relationships" xmlns:p="http://schemas.openxmlformats.org/presentationml/2006/main">
   <p:cSld>
+    <p:bg>
+      <p:bgPr>
+        <a:solidFill>
+          <a:srgbClr val="F0F3F8"/>
+        </a:solidFill>
+        <a:effectLst/>
+      </p:bgPr>
+    </p:bg>
     <p:spTree>
       <p:nvGrpSpPr>
         <p:cNvPr id="1" name="">
           <a:extLst>
             <a:ext uri="{FF2B5EF4-FFF2-40B4-BE49-F238E27FC236}">
-              <a16:creationId xmlns:a16="http://schemas.microsoft.com/office/drawing/2014/main" id="{6A6A8436-2B9F-D0CB-1E51-B718E6C3CDD9}"/>
+              <a16:creationId xmlns:a16="http://schemas.microsoft.com/office/drawing/2014/main" id="{8D2C3EB0-84D0-FF81-01D3-F1FAF665BE2B}"/>
             </a:ext>
           </a:extLst>
         </p:cNvPr>
@@ -4028,7 +4026,7 @@
           <p:cNvPr id="2" name="Title 1">
             <a:extLst>
               <a:ext uri="{FF2B5EF4-FFF2-40B4-BE49-F238E27FC236}">
-                <a16:creationId xmlns:a16="http://schemas.microsoft.com/office/drawing/2014/main" id="{21FE2EA1-5C6B-DC7D-938C-56CED3263889}"/>
+                <a16:creationId xmlns:a16="http://schemas.microsoft.com/office/drawing/2014/main" id="{B1B7D5F8-1202-C3A8-41EB-F6B998207019}"/>
               </a:ext>
             </a:extLst>
           </p:cNvPr>
@@ -4044,7 +4042,7 @@
           <a:bodyPr/>
           <a:lstStyle/>
           <a:p>
-            <a:endParaRPr lang="en-US" dirty="0"/>
+            <a:endParaRPr lang="en-US"/>
           </a:p>
         </p:txBody>
       </p:sp>
@@ -4053,7 +4051,7 @@
           <p:cNvPr id="3" name="Subtitle 2">
             <a:extLst>
               <a:ext uri="{FF2B5EF4-FFF2-40B4-BE49-F238E27FC236}">
-                <a16:creationId xmlns:a16="http://schemas.microsoft.com/office/drawing/2014/main" id="{5EFC4D62-020C-701C-FF14-A13E86EF8AC6}"/>
+                <a16:creationId xmlns:a16="http://schemas.microsoft.com/office/drawing/2014/main" id="{CD8C4F8B-FE4A-40E8-87D5-503D74CD4E88}"/>
               </a:ext>
             </a:extLst>
           </p:cNvPr>
@@ -4075,10 +4073,10 @@
       </p:sp>
       <p:pic>
         <p:nvPicPr>
-          <p:cNvPr id="6" name="Picture 5">
+          <p:cNvPr id="5" name="Picture 4">
             <a:extLst>
               <a:ext uri="{FF2B5EF4-FFF2-40B4-BE49-F238E27FC236}">
-                <a16:creationId xmlns:a16="http://schemas.microsoft.com/office/drawing/2014/main" id="{A633D2C6-4EBD-5296-67E3-5DF9177750F1}"/>
+                <a16:creationId xmlns:a16="http://schemas.microsoft.com/office/drawing/2014/main" id="{0A341794-3C82-14FA-0333-CBFD631B3A42}"/>
               </a:ext>
             </a:extLst>
           </p:cNvPr>
@@ -4101,8 +4099,38 @@
         </p:blipFill>
         <p:spPr>
           <a:xfrm>
-            <a:off x="0" y="198192"/>
-            <a:ext cx="9144000" cy="6461615"/>
+            <a:off x="16898" y="0"/>
+            <a:ext cx="8927641" cy="6308725"/>
+          </a:xfrm>
+          <a:prstGeom prst="rect">
+            <a:avLst/>
+          </a:prstGeom>
+        </p:spPr>
+      </p:pic>
+      <p:pic>
+        <p:nvPicPr>
+          <p:cNvPr id="4" name="Picture 3"/>
+          <p:cNvPicPr>
+            <a:picLocks noChangeAspect="1"/>
+          </p:cNvPicPr>
+          <p:nvPr/>
+        </p:nvPicPr>
+        <p:blipFill>
+          <a:blip r:embed="rId3">
+            <a:extLst>
+              <a:ext uri="{28A0092B-C50C-407E-A947-70E740481C1C}">
+                <a14:useLocalDpi xmlns:a14="http://schemas.microsoft.com/office/drawing/2010/main" val="0"/>
+              </a:ext>
+            </a:extLst>
+          </a:blip>
+          <a:stretch>
+            <a:fillRect/>
+          </a:stretch>
+        </p:blipFill>
+        <p:spPr>
+          <a:xfrm>
+            <a:off x="18896" y="0"/>
+            <a:ext cx="8923646" cy="6308725"/>
           </a:xfrm>
           <a:prstGeom prst="rect">
             <a:avLst/>
@@ -4112,28 +4140,45 @@
     </p:spTree>
     <p:extLst>
       <p:ext uri="{BB962C8B-B14F-4D97-AF65-F5344CB8AC3E}">
-        <p14:creationId xmlns:p14="http://schemas.microsoft.com/office/powerpoint/2010/main" val="1767742390"/>
+        <p14:creationId xmlns:p14="http://schemas.microsoft.com/office/powerpoint/2010/main" val="2661789739"/>
       </p:ext>
     </p:extLst>
   </p:cSld>
   <p:clrMapOvr>
     <a:masterClrMapping/>
   </p:clrMapOvr>
-  <p:transition>
-    <p:push dir="u"/>
-  </p:transition>
+  <mc:AlternateContent xmlns:mc="http://schemas.openxmlformats.org/markup-compatibility/2006" xmlns:p14="http://schemas.microsoft.com/office/powerpoint/2010/main">
+    <mc:Choice Requires="p14">
+      <p:transition spd="med" p14:dur="700">
+        <p:fade/>
+      </p:transition>
+    </mc:Choice>
+    <mc:Fallback xmlns="">
+      <p:transition spd="med">
+        <p:fade/>
+      </p:transition>
+    </mc:Fallback>
+  </mc:AlternateContent>
 </p:sld>
 </file>
 
-<file path=ppt/slides/slide9.xml><?xml version="1.0" encoding="utf-8"?>
+<file path=ppt/slides/slide3.xml><?xml version="1.0" encoding="utf-8"?>
 <p:sld xmlns:a="http://schemas.openxmlformats.org/drawingml/2006/main" xmlns:r="http://schemas.openxmlformats.org/officeDocument/2006/relationships" xmlns:p="http://schemas.openxmlformats.org/presentationml/2006/main">
   <p:cSld>
+    <p:bg>
+      <p:bgPr>
+        <a:solidFill>
+          <a:srgbClr val="F0F3F8"/>
+        </a:solidFill>
+        <a:effectLst/>
+      </p:bgPr>
+    </p:bg>
     <p:spTree>
       <p:nvGrpSpPr>
         <p:cNvPr id="1" name="">
           <a:extLst>
             <a:ext uri="{FF2B5EF4-FFF2-40B4-BE49-F238E27FC236}">
-              <a16:creationId xmlns:a16="http://schemas.microsoft.com/office/drawing/2014/main" id="{14CB0D43-71FF-C8FC-6142-4CDE94377A34}"/>
+              <a16:creationId xmlns:a16="http://schemas.microsoft.com/office/drawing/2014/main" id="{08677BFD-030E-D024-5DB4-F8ABC70D66E0}"/>
             </a:ext>
           </a:extLst>
         </p:cNvPr>
@@ -4153,7 +4198,7 @@
           <p:cNvPr id="2" name="Title 1">
             <a:extLst>
               <a:ext uri="{FF2B5EF4-FFF2-40B4-BE49-F238E27FC236}">
-                <a16:creationId xmlns:a16="http://schemas.microsoft.com/office/drawing/2014/main" id="{3D77EF50-088C-497C-3762-22F0B65AC84A}"/>
+                <a16:creationId xmlns:a16="http://schemas.microsoft.com/office/drawing/2014/main" id="{4C6F6707-AA98-35F5-00B8-0AB59467CA6A}"/>
               </a:ext>
             </a:extLst>
           </p:cNvPr>
@@ -4169,7 +4214,7 @@
           <a:bodyPr/>
           <a:lstStyle/>
           <a:p>
-            <a:endParaRPr lang="en-US" dirty="0"/>
+            <a:endParaRPr lang="en-US"/>
           </a:p>
         </p:txBody>
       </p:sp>
@@ -4178,7 +4223,7 @@
           <p:cNvPr id="3" name="Subtitle 2">
             <a:extLst>
               <a:ext uri="{FF2B5EF4-FFF2-40B4-BE49-F238E27FC236}">
-                <a16:creationId xmlns:a16="http://schemas.microsoft.com/office/drawing/2014/main" id="{362FA110-8633-C0CC-FE38-39CD098F3858}"/>
+                <a16:creationId xmlns:a16="http://schemas.microsoft.com/office/drawing/2014/main" id="{7390D148-EC86-48B6-C187-859BDF454121}"/>
               </a:ext>
             </a:extLst>
           </p:cNvPr>
@@ -4200,10 +4245,10 @@
       </p:sp>
       <p:pic>
         <p:nvPicPr>
-          <p:cNvPr id="6" name="Picture 5">
+          <p:cNvPr id="5" name="Picture 4">
             <a:extLst>
               <a:ext uri="{FF2B5EF4-FFF2-40B4-BE49-F238E27FC236}">
-                <a16:creationId xmlns:a16="http://schemas.microsoft.com/office/drawing/2014/main" id="{6C3E9AE3-73F8-4FAD-2D46-34667E270BC6}"/>
+                <a16:creationId xmlns:a16="http://schemas.microsoft.com/office/drawing/2014/main" id="{6471386A-EC90-3F46-739E-F767BAFB8495}"/>
               </a:ext>
             </a:extLst>
           </p:cNvPr>
@@ -4226,8 +4271,8 @@
         </p:blipFill>
         <p:spPr>
           <a:xfrm>
-            <a:off x="0" y="198192"/>
-            <a:ext cx="9144000" cy="6461615"/>
+            <a:off x="16898" y="0"/>
+            <a:ext cx="8927641" cy="6308725"/>
           </a:xfrm>
           <a:prstGeom prst="rect">
             <a:avLst/>
@@ -4237,16 +4282,877 @@
     </p:spTree>
     <p:extLst>
       <p:ext uri="{BB962C8B-B14F-4D97-AF65-F5344CB8AC3E}">
-        <p14:creationId xmlns:p14="http://schemas.microsoft.com/office/powerpoint/2010/main" val="2991928609"/>
+        <p14:creationId xmlns:p14="http://schemas.microsoft.com/office/powerpoint/2010/main" val="2907018688"/>
       </p:ext>
     </p:extLst>
   </p:cSld>
   <p:clrMapOvr>
     <a:masterClrMapping/>
   </p:clrMapOvr>
-  <p:transition>
-    <p:push dir="u"/>
-  </p:transition>
+  <mc:AlternateContent xmlns:mc="http://schemas.openxmlformats.org/markup-compatibility/2006" xmlns:p14="http://schemas.microsoft.com/office/powerpoint/2010/main">
+    <mc:Choice Requires="p14">
+      <p:transition spd="med" p14:dur="700">
+        <p:fade/>
+      </p:transition>
+    </mc:Choice>
+    <mc:Fallback xmlns="">
+      <p:transition spd="med">
+        <p:fade/>
+      </p:transition>
+    </mc:Fallback>
+  </mc:AlternateContent>
+</p:sld>
+</file>
+
+<file path=ppt/slides/slide4.xml><?xml version="1.0" encoding="utf-8"?>
+<p:sld xmlns:a="http://schemas.openxmlformats.org/drawingml/2006/main" xmlns:r="http://schemas.openxmlformats.org/officeDocument/2006/relationships" xmlns:p="http://schemas.openxmlformats.org/presentationml/2006/main">
+  <p:cSld>
+    <p:bg>
+      <p:bgPr>
+        <a:solidFill>
+          <a:srgbClr val="F0F3F8"/>
+        </a:solidFill>
+        <a:effectLst/>
+      </p:bgPr>
+    </p:bg>
+    <p:spTree>
+      <p:nvGrpSpPr>
+        <p:cNvPr id="1" name="">
+          <a:extLst>
+            <a:ext uri="{FF2B5EF4-FFF2-40B4-BE49-F238E27FC236}">
+              <a16:creationId xmlns:a16="http://schemas.microsoft.com/office/drawing/2014/main" id="{B5EE9839-B4F6-8541-62C1-5AD1BA10D295}"/>
+            </a:ext>
+          </a:extLst>
+        </p:cNvPr>
+        <p:cNvGrpSpPr/>
+        <p:nvPr/>
+      </p:nvGrpSpPr>
+      <p:grpSpPr>
+        <a:xfrm>
+          <a:off x="0" y="0"/>
+          <a:ext cx="0" cy="0"/>
+          <a:chOff x="0" y="0"/>
+          <a:chExt cx="0" cy="0"/>
+        </a:xfrm>
+      </p:grpSpPr>
+      <p:sp>
+        <p:nvSpPr>
+          <p:cNvPr id="2" name="Title 1">
+            <a:extLst>
+              <a:ext uri="{FF2B5EF4-FFF2-40B4-BE49-F238E27FC236}">
+                <a16:creationId xmlns:a16="http://schemas.microsoft.com/office/drawing/2014/main" id="{8B5F6446-8313-FB81-DC5A-C2217486C057}"/>
+              </a:ext>
+            </a:extLst>
+          </p:cNvPr>
+          <p:cNvSpPr>
+            <a:spLocks noGrp="1"/>
+          </p:cNvSpPr>
+          <p:nvPr>
+            <p:ph type="ctrTitle"/>
+          </p:nvPr>
+        </p:nvSpPr>
+        <p:spPr/>
+        <p:txBody>
+          <a:bodyPr/>
+          <a:lstStyle/>
+          <a:p>
+            <a:endParaRPr lang="en-US"/>
+          </a:p>
+        </p:txBody>
+      </p:sp>
+      <p:sp>
+        <p:nvSpPr>
+          <p:cNvPr id="3" name="Subtitle 2">
+            <a:extLst>
+              <a:ext uri="{FF2B5EF4-FFF2-40B4-BE49-F238E27FC236}">
+                <a16:creationId xmlns:a16="http://schemas.microsoft.com/office/drawing/2014/main" id="{DC1A931E-7F42-0323-A88A-45EF1B89E116}"/>
+              </a:ext>
+            </a:extLst>
+          </p:cNvPr>
+          <p:cNvSpPr>
+            <a:spLocks noGrp="1"/>
+          </p:cNvSpPr>
+          <p:nvPr>
+            <p:ph type="subTitle" idx="1"/>
+          </p:nvPr>
+        </p:nvSpPr>
+        <p:spPr/>
+        <p:txBody>
+          <a:bodyPr/>
+          <a:lstStyle/>
+          <a:p>
+            <a:endParaRPr lang="en-US"/>
+          </a:p>
+        </p:txBody>
+      </p:sp>
+      <p:pic>
+        <p:nvPicPr>
+          <p:cNvPr id="5" name="Picture 4">
+            <a:extLst>
+              <a:ext uri="{FF2B5EF4-FFF2-40B4-BE49-F238E27FC236}">
+                <a16:creationId xmlns:a16="http://schemas.microsoft.com/office/drawing/2014/main" id="{2E8FF718-6131-721B-4356-7EEB1A9360A8}"/>
+              </a:ext>
+            </a:extLst>
+          </p:cNvPr>
+          <p:cNvPicPr>
+            <a:picLocks noChangeAspect="1"/>
+          </p:cNvPicPr>
+          <p:nvPr/>
+        </p:nvPicPr>
+        <p:blipFill>
+          <a:blip r:embed="rId2">
+            <a:extLst>
+              <a:ext uri="{28A0092B-C50C-407E-A947-70E740481C1C}">
+                <a14:useLocalDpi xmlns:a14="http://schemas.microsoft.com/office/drawing/2010/main" val="0"/>
+              </a:ext>
+            </a:extLst>
+          </a:blip>
+          <a:stretch>
+            <a:fillRect/>
+          </a:stretch>
+        </p:blipFill>
+        <p:spPr>
+          <a:xfrm>
+            <a:off x="16898" y="0"/>
+            <a:ext cx="8927641" cy="6308725"/>
+          </a:xfrm>
+          <a:prstGeom prst="rect">
+            <a:avLst/>
+          </a:prstGeom>
+        </p:spPr>
+      </p:pic>
+    </p:spTree>
+    <p:extLst>
+      <p:ext uri="{BB962C8B-B14F-4D97-AF65-F5344CB8AC3E}">
+        <p14:creationId xmlns:p14="http://schemas.microsoft.com/office/powerpoint/2010/main" val="3924370106"/>
+      </p:ext>
+    </p:extLst>
+  </p:cSld>
+  <p:clrMapOvr>
+    <a:masterClrMapping/>
+  </p:clrMapOvr>
+  <mc:AlternateContent xmlns:mc="http://schemas.openxmlformats.org/markup-compatibility/2006" xmlns:p14="http://schemas.microsoft.com/office/powerpoint/2010/main">
+    <mc:Choice Requires="p14">
+      <p:transition spd="med" p14:dur="700">
+        <p:fade/>
+      </p:transition>
+    </mc:Choice>
+    <mc:Fallback xmlns="">
+      <p:transition spd="med">
+        <p:fade/>
+      </p:transition>
+    </mc:Fallback>
+  </mc:AlternateContent>
+</p:sld>
+</file>
+
+<file path=ppt/slides/slide5.xml><?xml version="1.0" encoding="utf-8"?>
+<p:sld xmlns:a="http://schemas.openxmlformats.org/drawingml/2006/main" xmlns:r="http://schemas.openxmlformats.org/officeDocument/2006/relationships" xmlns:p="http://schemas.openxmlformats.org/presentationml/2006/main">
+  <p:cSld>
+    <p:bg>
+      <p:bgPr>
+        <a:solidFill>
+          <a:srgbClr val="F0F3F8"/>
+        </a:solidFill>
+        <a:effectLst/>
+      </p:bgPr>
+    </p:bg>
+    <p:spTree>
+      <p:nvGrpSpPr>
+        <p:cNvPr id="1" name="">
+          <a:extLst>
+            <a:ext uri="{FF2B5EF4-FFF2-40B4-BE49-F238E27FC236}">
+              <a16:creationId xmlns:a16="http://schemas.microsoft.com/office/drawing/2014/main" id="{40935392-67DB-15E1-9DC0-712087719324}"/>
+            </a:ext>
+          </a:extLst>
+        </p:cNvPr>
+        <p:cNvGrpSpPr/>
+        <p:nvPr/>
+      </p:nvGrpSpPr>
+      <p:grpSpPr>
+        <a:xfrm>
+          <a:off x="0" y="0"/>
+          <a:ext cx="0" cy="0"/>
+          <a:chOff x="0" y="0"/>
+          <a:chExt cx="0" cy="0"/>
+        </a:xfrm>
+      </p:grpSpPr>
+      <p:sp>
+        <p:nvSpPr>
+          <p:cNvPr id="2" name="Title 1">
+            <a:extLst>
+              <a:ext uri="{FF2B5EF4-FFF2-40B4-BE49-F238E27FC236}">
+                <a16:creationId xmlns:a16="http://schemas.microsoft.com/office/drawing/2014/main" id="{BEE8292F-3C49-CA47-EB3F-79CE3AFB272D}"/>
+              </a:ext>
+            </a:extLst>
+          </p:cNvPr>
+          <p:cNvSpPr>
+            <a:spLocks noGrp="1"/>
+          </p:cNvSpPr>
+          <p:nvPr>
+            <p:ph type="ctrTitle"/>
+          </p:nvPr>
+        </p:nvSpPr>
+        <p:spPr/>
+        <p:txBody>
+          <a:bodyPr/>
+          <a:lstStyle/>
+          <a:p>
+            <a:endParaRPr lang="en-US"/>
+          </a:p>
+        </p:txBody>
+      </p:sp>
+      <p:sp>
+        <p:nvSpPr>
+          <p:cNvPr id="3" name="Subtitle 2">
+            <a:extLst>
+              <a:ext uri="{FF2B5EF4-FFF2-40B4-BE49-F238E27FC236}">
+                <a16:creationId xmlns:a16="http://schemas.microsoft.com/office/drawing/2014/main" id="{AE8E48B4-8304-D321-A577-15814BA94E6C}"/>
+              </a:ext>
+            </a:extLst>
+          </p:cNvPr>
+          <p:cNvSpPr>
+            <a:spLocks noGrp="1"/>
+          </p:cNvSpPr>
+          <p:nvPr>
+            <p:ph type="subTitle" idx="1"/>
+          </p:nvPr>
+        </p:nvSpPr>
+        <p:spPr/>
+        <p:txBody>
+          <a:bodyPr/>
+          <a:lstStyle/>
+          <a:p>
+            <a:endParaRPr lang="en-US"/>
+          </a:p>
+        </p:txBody>
+      </p:sp>
+      <p:pic>
+        <p:nvPicPr>
+          <p:cNvPr id="5" name="Picture 4">
+            <a:extLst>
+              <a:ext uri="{FF2B5EF4-FFF2-40B4-BE49-F238E27FC236}">
+                <a16:creationId xmlns:a16="http://schemas.microsoft.com/office/drawing/2014/main" id="{C33644EE-CFA5-182D-86F2-7C1EBDC31B03}"/>
+              </a:ext>
+            </a:extLst>
+          </p:cNvPr>
+          <p:cNvPicPr>
+            <a:picLocks noChangeAspect="1"/>
+          </p:cNvPicPr>
+          <p:nvPr/>
+        </p:nvPicPr>
+        <p:blipFill>
+          <a:blip r:embed="rId2">
+            <a:extLst>
+              <a:ext uri="{28A0092B-C50C-407E-A947-70E740481C1C}">
+                <a14:useLocalDpi xmlns:a14="http://schemas.microsoft.com/office/drawing/2010/main" val="0"/>
+              </a:ext>
+            </a:extLst>
+          </a:blip>
+          <a:stretch>
+            <a:fillRect/>
+          </a:stretch>
+        </p:blipFill>
+        <p:spPr>
+          <a:xfrm>
+            <a:off x="16898" y="0"/>
+            <a:ext cx="8927641" cy="6308725"/>
+          </a:xfrm>
+          <a:prstGeom prst="rect">
+            <a:avLst/>
+          </a:prstGeom>
+        </p:spPr>
+      </p:pic>
+    </p:spTree>
+    <p:extLst>
+      <p:ext uri="{BB962C8B-B14F-4D97-AF65-F5344CB8AC3E}">
+        <p14:creationId xmlns:p14="http://schemas.microsoft.com/office/powerpoint/2010/main" val="1303837968"/>
+      </p:ext>
+    </p:extLst>
+  </p:cSld>
+  <p:clrMapOvr>
+    <a:masterClrMapping/>
+  </p:clrMapOvr>
+  <mc:AlternateContent xmlns:mc="http://schemas.openxmlformats.org/markup-compatibility/2006" xmlns:p14="http://schemas.microsoft.com/office/powerpoint/2010/main">
+    <mc:Choice Requires="p14">
+      <p:transition spd="med" p14:dur="700">
+        <p:fade/>
+      </p:transition>
+    </mc:Choice>
+    <mc:Fallback xmlns="">
+      <p:transition spd="med">
+        <p:fade/>
+      </p:transition>
+    </mc:Fallback>
+  </mc:AlternateContent>
+</p:sld>
+</file>
+
+<file path=ppt/slides/slide6.xml><?xml version="1.0" encoding="utf-8"?>
+<p:sld xmlns:a="http://schemas.openxmlformats.org/drawingml/2006/main" xmlns:r="http://schemas.openxmlformats.org/officeDocument/2006/relationships" xmlns:p="http://schemas.openxmlformats.org/presentationml/2006/main">
+  <p:cSld>
+    <p:bg>
+      <p:bgPr>
+        <a:solidFill>
+          <a:srgbClr val="F0F3F8"/>
+        </a:solidFill>
+        <a:effectLst/>
+      </p:bgPr>
+    </p:bg>
+    <p:spTree>
+      <p:nvGrpSpPr>
+        <p:cNvPr id="1" name="">
+          <a:extLst>
+            <a:ext uri="{FF2B5EF4-FFF2-40B4-BE49-F238E27FC236}">
+              <a16:creationId xmlns:a16="http://schemas.microsoft.com/office/drawing/2014/main" id="{106BE298-EE7B-40F4-969B-836EA2819F58}"/>
+            </a:ext>
+          </a:extLst>
+        </p:cNvPr>
+        <p:cNvGrpSpPr/>
+        <p:nvPr/>
+      </p:nvGrpSpPr>
+      <p:grpSpPr>
+        <a:xfrm>
+          <a:off x="0" y="0"/>
+          <a:ext cx="0" cy="0"/>
+          <a:chOff x="0" y="0"/>
+          <a:chExt cx="0" cy="0"/>
+        </a:xfrm>
+      </p:grpSpPr>
+      <p:sp>
+        <p:nvSpPr>
+          <p:cNvPr id="2" name="Title 1">
+            <a:extLst>
+              <a:ext uri="{FF2B5EF4-FFF2-40B4-BE49-F238E27FC236}">
+                <a16:creationId xmlns:a16="http://schemas.microsoft.com/office/drawing/2014/main" id="{539D755F-E6D9-D5C0-355E-F257716F36FF}"/>
+              </a:ext>
+            </a:extLst>
+          </p:cNvPr>
+          <p:cNvSpPr>
+            <a:spLocks noGrp="1"/>
+          </p:cNvSpPr>
+          <p:nvPr>
+            <p:ph type="ctrTitle"/>
+          </p:nvPr>
+        </p:nvSpPr>
+        <p:spPr/>
+        <p:txBody>
+          <a:bodyPr/>
+          <a:lstStyle/>
+          <a:p>
+            <a:endParaRPr lang="en-US"/>
+          </a:p>
+        </p:txBody>
+      </p:sp>
+      <p:sp>
+        <p:nvSpPr>
+          <p:cNvPr id="3" name="Subtitle 2">
+            <a:extLst>
+              <a:ext uri="{FF2B5EF4-FFF2-40B4-BE49-F238E27FC236}">
+                <a16:creationId xmlns:a16="http://schemas.microsoft.com/office/drawing/2014/main" id="{59282CCE-0832-261A-A8E7-B75D13E801E4}"/>
+              </a:ext>
+            </a:extLst>
+          </p:cNvPr>
+          <p:cNvSpPr>
+            <a:spLocks noGrp="1"/>
+          </p:cNvSpPr>
+          <p:nvPr>
+            <p:ph type="subTitle" idx="1"/>
+          </p:nvPr>
+        </p:nvSpPr>
+        <p:spPr/>
+        <p:txBody>
+          <a:bodyPr/>
+          <a:lstStyle/>
+          <a:p>
+            <a:endParaRPr lang="en-US"/>
+          </a:p>
+        </p:txBody>
+      </p:sp>
+      <p:pic>
+        <p:nvPicPr>
+          <p:cNvPr id="5" name="Picture 4">
+            <a:extLst>
+              <a:ext uri="{FF2B5EF4-FFF2-40B4-BE49-F238E27FC236}">
+                <a16:creationId xmlns:a16="http://schemas.microsoft.com/office/drawing/2014/main" id="{54676C01-F43A-FA41-9DA9-C1F8E8B601A5}"/>
+              </a:ext>
+            </a:extLst>
+          </p:cNvPr>
+          <p:cNvPicPr>
+            <a:picLocks noChangeAspect="1"/>
+          </p:cNvPicPr>
+          <p:nvPr/>
+        </p:nvPicPr>
+        <p:blipFill>
+          <a:blip r:embed="rId2">
+            <a:extLst>
+              <a:ext uri="{28A0092B-C50C-407E-A947-70E740481C1C}">
+                <a14:useLocalDpi xmlns:a14="http://schemas.microsoft.com/office/drawing/2010/main" val="0"/>
+              </a:ext>
+            </a:extLst>
+          </a:blip>
+          <a:stretch>
+            <a:fillRect/>
+          </a:stretch>
+        </p:blipFill>
+        <p:spPr>
+          <a:xfrm>
+            <a:off x="16898" y="0"/>
+            <a:ext cx="8927641" cy="6308725"/>
+          </a:xfrm>
+          <a:prstGeom prst="rect">
+            <a:avLst/>
+          </a:prstGeom>
+        </p:spPr>
+      </p:pic>
+    </p:spTree>
+    <p:extLst>
+      <p:ext uri="{BB962C8B-B14F-4D97-AF65-F5344CB8AC3E}">
+        <p14:creationId xmlns:p14="http://schemas.microsoft.com/office/powerpoint/2010/main" val="614972680"/>
+      </p:ext>
+    </p:extLst>
+  </p:cSld>
+  <p:clrMapOvr>
+    <a:masterClrMapping/>
+  </p:clrMapOvr>
+  <mc:AlternateContent xmlns:mc="http://schemas.openxmlformats.org/markup-compatibility/2006" xmlns:p14="http://schemas.microsoft.com/office/powerpoint/2010/main">
+    <mc:Choice Requires="p14">
+      <p:transition spd="med" p14:dur="700">
+        <p:fade/>
+      </p:transition>
+    </mc:Choice>
+    <mc:Fallback xmlns="">
+      <p:transition spd="med">
+        <p:fade/>
+      </p:transition>
+    </mc:Fallback>
+  </mc:AlternateContent>
+</p:sld>
+</file>
+
+<file path=ppt/slides/slide7.xml><?xml version="1.0" encoding="utf-8"?>
+<p:sld xmlns:a="http://schemas.openxmlformats.org/drawingml/2006/main" xmlns:r="http://schemas.openxmlformats.org/officeDocument/2006/relationships" xmlns:p="http://schemas.openxmlformats.org/presentationml/2006/main">
+  <p:cSld>
+    <p:bg>
+      <p:bgPr>
+        <a:solidFill>
+          <a:srgbClr val="F0F3F8"/>
+        </a:solidFill>
+        <a:effectLst/>
+      </p:bgPr>
+    </p:bg>
+    <p:spTree>
+      <p:nvGrpSpPr>
+        <p:cNvPr id="1" name="">
+          <a:extLst>
+            <a:ext uri="{FF2B5EF4-FFF2-40B4-BE49-F238E27FC236}">
+              <a16:creationId xmlns:a16="http://schemas.microsoft.com/office/drawing/2014/main" id="{B6727B69-63B7-EA7A-5D0D-3C9736C7CC63}"/>
+            </a:ext>
+          </a:extLst>
+        </p:cNvPr>
+        <p:cNvGrpSpPr/>
+        <p:nvPr/>
+      </p:nvGrpSpPr>
+      <p:grpSpPr>
+        <a:xfrm>
+          <a:off x="0" y="0"/>
+          <a:ext cx="0" cy="0"/>
+          <a:chOff x="0" y="0"/>
+          <a:chExt cx="0" cy="0"/>
+        </a:xfrm>
+      </p:grpSpPr>
+      <p:sp>
+        <p:nvSpPr>
+          <p:cNvPr id="2" name="Title 1">
+            <a:extLst>
+              <a:ext uri="{FF2B5EF4-FFF2-40B4-BE49-F238E27FC236}">
+                <a16:creationId xmlns:a16="http://schemas.microsoft.com/office/drawing/2014/main" id="{C51E3306-D29E-5811-4436-CE079D648B8A}"/>
+              </a:ext>
+            </a:extLst>
+          </p:cNvPr>
+          <p:cNvSpPr>
+            <a:spLocks noGrp="1"/>
+          </p:cNvSpPr>
+          <p:nvPr>
+            <p:ph type="ctrTitle"/>
+          </p:nvPr>
+        </p:nvSpPr>
+        <p:spPr/>
+        <p:txBody>
+          <a:bodyPr/>
+          <a:lstStyle/>
+          <a:p>
+            <a:endParaRPr lang="en-US"/>
+          </a:p>
+        </p:txBody>
+      </p:sp>
+      <p:sp>
+        <p:nvSpPr>
+          <p:cNvPr id="3" name="Subtitle 2">
+            <a:extLst>
+              <a:ext uri="{FF2B5EF4-FFF2-40B4-BE49-F238E27FC236}">
+                <a16:creationId xmlns:a16="http://schemas.microsoft.com/office/drawing/2014/main" id="{07DC03EC-20A1-B7A0-CA39-E6688051BCA8}"/>
+              </a:ext>
+            </a:extLst>
+          </p:cNvPr>
+          <p:cNvSpPr>
+            <a:spLocks noGrp="1"/>
+          </p:cNvSpPr>
+          <p:nvPr>
+            <p:ph type="subTitle" idx="1"/>
+          </p:nvPr>
+        </p:nvSpPr>
+        <p:spPr/>
+        <p:txBody>
+          <a:bodyPr/>
+          <a:lstStyle/>
+          <a:p>
+            <a:endParaRPr lang="en-US"/>
+          </a:p>
+        </p:txBody>
+      </p:sp>
+      <p:pic>
+        <p:nvPicPr>
+          <p:cNvPr id="5" name="Picture 4">
+            <a:extLst>
+              <a:ext uri="{FF2B5EF4-FFF2-40B4-BE49-F238E27FC236}">
+                <a16:creationId xmlns:a16="http://schemas.microsoft.com/office/drawing/2014/main" id="{256ACA9C-6A70-A911-4D3A-1541993C084B}"/>
+              </a:ext>
+            </a:extLst>
+          </p:cNvPr>
+          <p:cNvPicPr>
+            <a:picLocks noChangeAspect="1"/>
+          </p:cNvPicPr>
+          <p:nvPr/>
+        </p:nvPicPr>
+        <p:blipFill>
+          <a:blip r:embed="rId2">
+            <a:extLst>
+              <a:ext uri="{28A0092B-C50C-407E-A947-70E740481C1C}">
+                <a14:useLocalDpi xmlns:a14="http://schemas.microsoft.com/office/drawing/2010/main" val="0"/>
+              </a:ext>
+            </a:extLst>
+          </a:blip>
+          <a:stretch>
+            <a:fillRect/>
+          </a:stretch>
+        </p:blipFill>
+        <p:spPr>
+          <a:xfrm>
+            <a:off x="16898" y="0"/>
+            <a:ext cx="8927641" cy="6308725"/>
+          </a:xfrm>
+          <a:prstGeom prst="rect">
+            <a:avLst/>
+          </a:prstGeom>
+        </p:spPr>
+      </p:pic>
+    </p:spTree>
+    <p:extLst>
+      <p:ext uri="{BB962C8B-B14F-4D97-AF65-F5344CB8AC3E}">
+        <p14:creationId xmlns:p14="http://schemas.microsoft.com/office/powerpoint/2010/main" val="3570878566"/>
+      </p:ext>
+    </p:extLst>
+  </p:cSld>
+  <p:clrMapOvr>
+    <a:masterClrMapping/>
+  </p:clrMapOvr>
+  <mc:AlternateContent xmlns:mc="http://schemas.openxmlformats.org/markup-compatibility/2006" xmlns:p14="http://schemas.microsoft.com/office/powerpoint/2010/main">
+    <mc:Choice Requires="p14">
+      <p:transition spd="med" p14:dur="700">
+        <p:fade/>
+      </p:transition>
+    </mc:Choice>
+    <mc:Fallback xmlns="">
+      <p:transition spd="med">
+        <p:fade/>
+      </p:transition>
+    </mc:Fallback>
+  </mc:AlternateContent>
+</p:sld>
+</file>
+
+<file path=ppt/slides/slide8.xml><?xml version="1.0" encoding="utf-8"?>
+<p:sld xmlns:a="http://schemas.openxmlformats.org/drawingml/2006/main" xmlns:r="http://schemas.openxmlformats.org/officeDocument/2006/relationships" xmlns:p="http://schemas.openxmlformats.org/presentationml/2006/main">
+  <p:cSld>
+    <p:bg>
+      <p:bgPr>
+        <a:solidFill>
+          <a:srgbClr val="F0F3F8"/>
+        </a:solidFill>
+        <a:effectLst/>
+      </p:bgPr>
+    </p:bg>
+    <p:spTree>
+      <p:nvGrpSpPr>
+        <p:cNvPr id="1" name="">
+          <a:extLst>
+            <a:ext uri="{FF2B5EF4-FFF2-40B4-BE49-F238E27FC236}">
+              <a16:creationId xmlns:a16="http://schemas.microsoft.com/office/drawing/2014/main" id="{6E2A0A53-C843-7235-E53A-E189B67B36EC}"/>
+            </a:ext>
+          </a:extLst>
+        </p:cNvPr>
+        <p:cNvGrpSpPr/>
+        <p:nvPr/>
+      </p:nvGrpSpPr>
+      <p:grpSpPr>
+        <a:xfrm>
+          <a:off x="0" y="0"/>
+          <a:ext cx="0" cy="0"/>
+          <a:chOff x="0" y="0"/>
+          <a:chExt cx="0" cy="0"/>
+        </a:xfrm>
+      </p:grpSpPr>
+      <p:sp>
+        <p:nvSpPr>
+          <p:cNvPr id="2" name="Title 1">
+            <a:extLst>
+              <a:ext uri="{FF2B5EF4-FFF2-40B4-BE49-F238E27FC236}">
+                <a16:creationId xmlns:a16="http://schemas.microsoft.com/office/drawing/2014/main" id="{BA0B2F48-1517-F04F-4EF6-79BD9F8AAB6D}"/>
+              </a:ext>
+            </a:extLst>
+          </p:cNvPr>
+          <p:cNvSpPr>
+            <a:spLocks noGrp="1"/>
+          </p:cNvSpPr>
+          <p:nvPr>
+            <p:ph type="ctrTitle"/>
+          </p:nvPr>
+        </p:nvSpPr>
+        <p:spPr/>
+        <p:txBody>
+          <a:bodyPr/>
+          <a:lstStyle/>
+          <a:p>
+            <a:endParaRPr lang="en-US"/>
+          </a:p>
+        </p:txBody>
+      </p:sp>
+      <p:sp>
+        <p:nvSpPr>
+          <p:cNvPr id="3" name="Subtitle 2">
+            <a:extLst>
+              <a:ext uri="{FF2B5EF4-FFF2-40B4-BE49-F238E27FC236}">
+                <a16:creationId xmlns:a16="http://schemas.microsoft.com/office/drawing/2014/main" id="{3951C911-D5B9-1FB0-3ACD-0C0D89DB7E79}"/>
+              </a:ext>
+            </a:extLst>
+          </p:cNvPr>
+          <p:cNvSpPr>
+            <a:spLocks noGrp="1"/>
+          </p:cNvSpPr>
+          <p:nvPr>
+            <p:ph type="subTitle" idx="1"/>
+          </p:nvPr>
+        </p:nvSpPr>
+        <p:spPr/>
+        <p:txBody>
+          <a:bodyPr/>
+          <a:lstStyle/>
+          <a:p>
+            <a:endParaRPr lang="en-US"/>
+          </a:p>
+        </p:txBody>
+      </p:sp>
+      <p:pic>
+        <p:nvPicPr>
+          <p:cNvPr id="5" name="Picture 4">
+            <a:extLst>
+              <a:ext uri="{FF2B5EF4-FFF2-40B4-BE49-F238E27FC236}">
+                <a16:creationId xmlns:a16="http://schemas.microsoft.com/office/drawing/2014/main" id="{CD080A9E-F90F-42E8-F71E-A3F0DE8B2FEF}"/>
+              </a:ext>
+            </a:extLst>
+          </p:cNvPr>
+          <p:cNvPicPr>
+            <a:picLocks noChangeAspect="1"/>
+          </p:cNvPicPr>
+          <p:nvPr/>
+        </p:nvPicPr>
+        <p:blipFill>
+          <a:blip r:embed="rId2">
+            <a:extLst>
+              <a:ext uri="{28A0092B-C50C-407E-A947-70E740481C1C}">
+                <a14:useLocalDpi xmlns:a14="http://schemas.microsoft.com/office/drawing/2010/main" val="0"/>
+              </a:ext>
+            </a:extLst>
+          </a:blip>
+          <a:stretch>
+            <a:fillRect/>
+          </a:stretch>
+        </p:blipFill>
+        <p:spPr>
+          <a:xfrm>
+            <a:off x="16898" y="0"/>
+            <a:ext cx="8927641" cy="6308725"/>
+          </a:xfrm>
+          <a:prstGeom prst="rect">
+            <a:avLst/>
+          </a:prstGeom>
+        </p:spPr>
+      </p:pic>
+    </p:spTree>
+    <p:extLst>
+      <p:ext uri="{BB962C8B-B14F-4D97-AF65-F5344CB8AC3E}">
+        <p14:creationId xmlns:p14="http://schemas.microsoft.com/office/powerpoint/2010/main" val="2751171573"/>
+      </p:ext>
+    </p:extLst>
+  </p:cSld>
+  <p:clrMapOvr>
+    <a:masterClrMapping/>
+  </p:clrMapOvr>
+  <mc:AlternateContent xmlns:mc="http://schemas.openxmlformats.org/markup-compatibility/2006" xmlns:p14="http://schemas.microsoft.com/office/powerpoint/2010/main">
+    <mc:Choice Requires="p14">
+      <p:transition spd="med" p14:dur="700">
+        <p:fade/>
+      </p:transition>
+    </mc:Choice>
+    <mc:Fallback xmlns="">
+      <p:transition spd="med">
+        <p:fade/>
+      </p:transition>
+    </mc:Fallback>
+  </mc:AlternateContent>
+</p:sld>
+</file>
+
+<file path=ppt/slides/slide9.xml><?xml version="1.0" encoding="utf-8"?>
+<p:sld xmlns:a="http://schemas.openxmlformats.org/drawingml/2006/main" xmlns:r="http://schemas.openxmlformats.org/officeDocument/2006/relationships" xmlns:p="http://schemas.openxmlformats.org/presentationml/2006/main">
+  <p:cSld>
+    <p:bg>
+      <p:bgPr>
+        <a:solidFill>
+          <a:srgbClr val="F0F3F8"/>
+        </a:solidFill>
+        <a:effectLst/>
+      </p:bgPr>
+    </p:bg>
+    <p:spTree>
+      <p:nvGrpSpPr>
+        <p:cNvPr id="1" name="">
+          <a:extLst>
+            <a:ext uri="{FF2B5EF4-FFF2-40B4-BE49-F238E27FC236}">
+              <a16:creationId xmlns:a16="http://schemas.microsoft.com/office/drawing/2014/main" id="{8326D8DD-8260-66F8-EC77-B60F6A349DE3}"/>
+            </a:ext>
+          </a:extLst>
+        </p:cNvPr>
+        <p:cNvGrpSpPr/>
+        <p:nvPr/>
+      </p:nvGrpSpPr>
+      <p:grpSpPr>
+        <a:xfrm>
+          <a:off x="0" y="0"/>
+          <a:ext cx="0" cy="0"/>
+          <a:chOff x="0" y="0"/>
+          <a:chExt cx="0" cy="0"/>
+        </a:xfrm>
+      </p:grpSpPr>
+      <p:sp>
+        <p:nvSpPr>
+          <p:cNvPr id="2" name="Title 1">
+            <a:extLst>
+              <a:ext uri="{FF2B5EF4-FFF2-40B4-BE49-F238E27FC236}">
+                <a16:creationId xmlns:a16="http://schemas.microsoft.com/office/drawing/2014/main" id="{8B8C2577-21FE-4CCA-38AA-26E7D8ABC781}"/>
+              </a:ext>
+            </a:extLst>
+          </p:cNvPr>
+          <p:cNvSpPr>
+            <a:spLocks noGrp="1"/>
+          </p:cNvSpPr>
+          <p:nvPr>
+            <p:ph type="ctrTitle"/>
+          </p:nvPr>
+        </p:nvSpPr>
+        <p:spPr/>
+        <p:txBody>
+          <a:bodyPr/>
+          <a:lstStyle/>
+          <a:p>
+            <a:endParaRPr lang="en-US"/>
+          </a:p>
+        </p:txBody>
+      </p:sp>
+      <p:sp>
+        <p:nvSpPr>
+          <p:cNvPr id="3" name="Subtitle 2">
+            <a:extLst>
+              <a:ext uri="{FF2B5EF4-FFF2-40B4-BE49-F238E27FC236}">
+                <a16:creationId xmlns:a16="http://schemas.microsoft.com/office/drawing/2014/main" id="{BA039780-4330-2978-DA87-472ADAA44EF0}"/>
+              </a:ext>
+            </a:extLst>
+          </p:cNvPr>
+          <p:cNvSpPr>
+            <a:spLocks noGrp="1"/>
+          </p:cNvSpPr>
+          <p:nvPr>
+            <p:ph type="subTitle" idx="1"/>
+          </p:nvPr>
+        </p:nvSpPr>
+        <p:spPr/>
+        <p:txBody>
+          <a:bodyPr/>
+          <a:lstStyle/>
+          <a:p>
+            <a:endParaRPr lang="en-US"/>
+          </a:p>
+        </p:txBody>
+      </p:sp>
+      <p:pic>
+        <p:nvPicPr>
+          <p:cNvPr id="5" name="Picture 4">
+            <a:extLst>
+              <a:ext uri="{FF2B5EF4-FFF2-40B4-BE49-F238E27FC236}">
+                <a16:creationId xmlns:a16="http://schemas.microsoft.com/office/drawing/2014/main" id="{5457F56C-4B9F-8498-D653-86A4217734B1}"/>
+              </a:ext>
+            </a:extLst>
+          </p:cNvPr>
+          <p:cNvPicPr>
+            <a:picLocks noChangeAspect="1"/>
+          </p:cNvPicPr>
+          <p:nvPr/>
+        </p:nvPicPr>
+        <p:blipFill>
+          <a:blip r:embed="rId2">
+            <a:extLst>
+              <a:ext uri="{28A0092B-C50C-407E-A947-70E740481C1C}">
+                <a14:useLocalDpi xmlns:a14="http://schemas.microsoft.com/office/drawing/2010/main" val="0"/>
+              </a:ext>
+            </a:extLst>
+          </a:blip>
+          <a:stretch>
+            <a:fillRect/>
+          </a:stretch>
+        </p:blipFill>
+        <p:spPr>
+          <a:xfrm>
+            <a:off x="16898" y="0"/>
+            <a:ext cx="8927641" cy="6308725"/>
+          </a:xfrm>
+          <a:prstGeom prst="rect">
+            <a:avLst/>
+          </a:prstGeom>
+        </p:spPr>
+      </p:pic>
+    </p:spTree>
+    <p:extLst>
+      <p:ext uri="{BB962C8B-B14F-4D97-AF65-F5344CB8AC3E}">
+        <p14:creationId xmlns:p14="http://schemas.microsoft.com/office/powerpoint/2010/main" val="1756270321"/>
+      </p:ext>
+    </p:extLst>
+  </p:cSld>
+  <p:clrMapOvr>
+    <a:masterClrMapping/>
+  </p:clrMapOvr>
+  <mc:AlternateContent xmlns:mc="http://schemas.openxmlformats.org/markup-compatibility/2006" xmlns:p14="http://schemas.microsoft.com/office/powerpoint/2010/main">
+    <mc:Choice Requires="p14">
+      <p:transition spd="med" p14:dur="700">
+        <p:fade/>
+      </p:transition>
+    </mc:Choice>
+    <mc:Fallback xmlns="">
+      <p:transition spd="med">
+        <p:fade/>
+      </p:transition>
+    </mc:Fallback>
+  </mc:AlternateContent>
 </p:sld>
 </file>
 

</xml_diff>